<commit_message>
fix(formations): matrix overflow on slide 4 (α/β)
La formule de positionnement des cellules de la matrice 2×2 décalait
tout d'une colonne vers la droite : cellule droite allait jusqu'à x=17.5
alors que le slide fait 13.33 de large.

- Renommé mx/my en cellX/cellY (cellX = colonne de gauche des cellules)
- Formule cellule : cellX + col*cw au lieu de mx + cw + col*cw
- Étiquettes de rangées alignées à droite, juste à gauche des cellules
- cw légèrement réduit (4.95 au lieu de 5) pour pousser une marge propre
  à droite

Tous les autres slides restent dans les bornes (vérifié à la main).
</commit_message>
<xml_diff>
--- a/formations/output/biostat-module-1-fondations.pptx
+++ b/formations/output/biostat-module-1-fondations.pptx
@@ -9098,8 +9098,8 @@
         </p:nvSpPr>
         <p:spPr>
           <a:xfrm>
-            <a:off x="6858000" y="2606040"/>
-            <a:ext cx="9144000" cy="274320"/>
+            <a:off x="2377440" y="2834640"/>
+            <a:ext cx="9052560" cy="274320"/>
           </a:xfrm>
           <a:prstGeom prst="rect">
             <a:avLst/>
@@ -9137,8 +9137,8 @@
         </p:nvSpPr>
         <p:spPr>
           <a:xfrm>
-            <a:off x="6858000" y="2880360"/>
-            <a:ext cx="4572000" cy="228600"/>
+            <a:off x="2377440" y="3108960"/>
+            <a:ext cx="4526280" cy="228600"/>
           </a:xfrm>
           <a:prstGeom prst="rect">
             <a:avLst/>
@@ -9176,8 +9176,8 @@
         </p:nvSpPr>
         <p:spPr>
           <a:xfrm>
-            <a:off x="11430000" y="2880360"/>
-            <a:ext cx="4572000" cy="228600"/>
+            <a:off x="6903720" y="3108960"/>
+            <a:ext cx="4526280" cy="228600"/>
           </a:xfrm>
           <a:prstGeom prst="rect">
             <a:avLst/>
@@ -9215,20 +9215,20 @@
         </p:nvSpPr>
         <p:spPr>
           <a:xfrm>
-            <a:off x="822960" y="3566160"/>
-            <a:ext cx="1371600" cy="548640"/>
-          </a:xfrm>
-          <a:prstGeom prst="rect">
-            <a:avLst/>
-          </a:prstGeom>
-          <a:noFill/>
-          <a:ln/>
-        </p:spPr>
-        <p:txBody>
-          <a:bodyPr wrap="square" rtlCol="0" anchor="ctr"/>
-          <a:lstStyle/>
-          <a:p>
-            <a:pPr indent="0" marL="0">
+            <a:off x="457200" y="2834640"/>
+            <a:ext cx="1737360" cy="548640"/>
+          </a:xfrm>
+          <a:prstGeom prst="rect">
+            <a:avLst/>
+          </a:prstGeom>
+          <a:noFill/>
+          <a:ln/>
+        </p:spPr>
+        <p:txBody>
+          <a:bodyPr wrap="square" rtlCol="0" anchor="ctr"/>
+          <a:lstStyle/>
+          <a:p>
+            <a:pPr algn="r" indent="0" marL="0">
               <a:lnSpc>
                 <a:spcPct val="120000"/>
               </a:lnSpc>
@@ -9248,7 +9248,7 @@
             <a:endParaRPr lang="en-US" sz="1000" dirty="0"/>
           </a:p>
           <a:p>
-            <a:pPr indent="0" marL="0">
+            <a:pPr algn="r" indent="0" marL="0">
               <a:lnSpc>
                 <a:spcPct val="120000"/>
               </a:lnSpc>
@@ -9277,20 +9277,23 @@
         </p:nvSpPr>
         <p:spPr>
           <a:xfrm>
-            <a:off x="822960" y="3291840"/>
-            <a:ext cx="1371600" cy="1188720"/>
-          </a:xfrm>
-          <a:prstGeom prst="rect">
-            <a:avLst/>
-          </a:prstGeom>
-          <a:noFill/>
-          <a:ln/>
-        </p:spPr>
-        <p:txBody>
-          <a:bodyPr wrap="square" rtlCol="0" anchor="ctr"/>
-          <a:lstStyle/>
-          <a:p>
-            <a:pPr indent="0" marL="0">
+            <a:off x="457200" y="3383280"/>
+            <a:ext cx="1783080" cy="1143000"/>
+          </a:xfrm>
+          <a:prstGeom prst="rect">
+            <a:avLst/>
+          </a:prstGeom>
+          <a:noFill/>
+          <a:ln/>
+        </p:spPr>
+        <p:txBody>
+          <a:bodyPr wrap="square" rtlCol="0" anchor="ctr"/>
+          <a:lstStyle/>
+          <a:p>
+            <a:pPr algn="r" indent="0" marL="0">
+              <a:lnSpc>
+                <a:spcPct val="120000"/>
+              </a:lnSpc>
               <a:buNone/>
             </a:pPr>
             <a:r>
@@ -9302,10 +9305,30 @@
                 <a:ea typeface="Calibri" pitchFamily="34" charset="-122"/>
                 <a:cs typeface="Calibri" pitchFamily="34" charset="-120"/>
               </a:rPr>
-              <a:t>Ne pas rejeter H₀</a:t>
+              <a:t>Ne pas</a:t>
             </a:r>
             <a:endParaRPr lang="en-US" sz="1200" dirty="0"/>
           </a:p>
+          <a:p>
+            <a:pPr algn="r" indent="0" marL="0">
+              <a:lnSpc>
+                <a:spcPct val="120000"/>
+              </a:lnSpc>
+              <a:buNone/>
+            </a:pPr>
+            <a:r>
+              <a:rPr lang="en-US" sz="1200" b="1" dirty="0">
+                <a:solidFill>
+                  <a:srgbClr val="15233F"/>
+                </a:solidFill>
+                <a:latin typeface="Calibri" pitchFamily="34" charset="0"/>
+                <a:ea typeface="Calibri" pitchFamily="34" charset="-122"/>
+                <a:cs typeface="Calibri" pitchFamily="34" charset="-120"/>
+              </a:rPr>
+              <a:t>rejeter H₀</a:t>
+            </a:r>
+            <a:endParaRPr lang="en-US" sz="1200" dirty="0"/>
+          </a:p>
         </p:txBody>
       </p:sp>
       <p:sp>
@@ -9316,20 +9339,20 @@
         </p:nvSpPr>
         <p:spPr>
           <a:xfrm>
-            <a:off x="822960" y="4480560"/>
-            <a:ext cx="1371600" cy="1188720"/>
-          </a:xfrm>
-          <a:prstGeom prst="rect">
-            <a:avLst/>
-          </a:prstGeom>
-          <a:noFill/>
-          <a:ln/>
-        </p:spPr>
-        <p:txBody>
-          <a:bodyPr wrap="square" rtlCol="0" anchor="ctr"/>
-          <a:lstStyle/>
-          <a:p>
-            <a:pPr indent="0" marL="0">
+            <a:off x="457200" y="4526280"/>
+            <a:ext cx="1783080" cy="1143000"/>
+          </a:xfrm>
+          <a:prstGeom prst="rect">
+            <a:avLst/>
+          </a:prstGeom>
+          <a:noFill/>
+          <a:ln/>
+        </p:spPr>
+        <p:txBody>
+          <a:bodyPr wrap="square" rtlCol="0" anchor="ctr"/>
+          <a:lstStyle/>
+          <a:p>
+            <a:pPr algn="r" indent="0" marL="0">
               <a:buNone/>
             </a:pPr>
             <a:r>
@@ -9355,8 +9378,8 @@
         </p:nvSpPr>
         <p:spPr>
           <a:xfrm>
-            <a:off x="6858000" y="3291840"/>
-            <a:ext cx="4572000" cy="1188720"/>
+            <a:off x="2377440" y="3383280"/>
+            <a:ext cx="4526280" cy="1143000"/>
           </a:xfrm>
           <a:prstGeom prst="rect">
             <a:avLst/>
@@ -9380,8 +9403,8 @@
         </p:nvSpPr>
         <p:spPr>
           <a:xfrm>
-            <a:off x="6949440" y="3383280"/>
-            <a:ext cx="4389120" cy="457200"/>
+            <a:off x="2468880" y="3474720"/>
+            <a:ext cx="4343400" cy="411480"/>
           </a:xfrm>
           <a:prstGeom prst="rect">
             <a:avLst/>
@@ -9397,7 +9420,7 @@
               <a:buNone/>
             </a:pPr>
             <a:r>
-              <a:rPr lang="en-US" sz="1800" b="1" dirty="0">
+              <a:rPr lang="en-US" sz="1700" b="1" dirty="0">
                 <a:solidFill>
                   <a:srgbClr val="15233F"/>
                 </a:solidFill>
@@ -9407,7 +9430,7 @@
               </a:rPr>
               <a:t>Bonne décision</a:t>
             </a:r>
-            <a:endParaRPr lang="en-US" sz="1800" dirty="0"/>
+            <a:endParaRPr lang="en-US" sz="1700" dirty="0"/>
           </a:p>
         </p:txBody>
       </p:sp>
@@ -9419,8 +9442,8 @@
         </p:nvSpPr>
         <p:spPr>
           <a:xfrm>
-            <a:off x="6949440" y="3886200"/>
-            <a:ext cx="4389120" cy="548640"/>
+            <a:off x="2468880" y="3931920"/>
+            <a:ext cx="4343400" cy="548640"/>
           </a:xfrm>
           <a:prstGeom prst="rect">
             <a:avLst/>
@@ -9461,8 +9484,8 @@
         </p:nvSpPr>
         <p:spPr>
           <a:xfrm>
-            <a:off x="11430000" y="3291840"/>
-            <a:ext cx="4572000" cy="1188720"/>
+            <a:off x="6903720" y="3383280"/>
+            <a:ext cx="4526280" cy="1143000"/>
           </a:xfrm>
           <a:prstGeom prst="rect">
             <a:avLst/>
@@ -9486,8 +9509,8 @@
         </p:nvSpPr>
         <p:spPr>
           <a:xfrm>
-            <a:off x="11521440" y="3383280"/>
-            <a:ext cx="4389120" cy="457200"/>
+            <a:off x="6995160" y="3474720"/>
+            <a:ext cx="4343400" cy="411480"/>
           </a:xfrm>
           <a:prstGeom prst="rect">
             <a:avLst/>
@@ -9503,7 +9526,7 @@
               <a:buNone/>
             </a:pPr>
             <a:r>
-              <a:rPr lang="en-US" sz="1800" b="1" dirty="0">
+              <a:rPr lang="en-US" sz="1700" b="1" dirty="0">
                 <a:solidFill>
                   <a:srgbClr val="E74C3C"/>
                 </a:solidFill>
@@ -9513,7 +9536,7 @@
               </a:rPr>
               <a:t>Erreur β</a:t>
             </a:r>
-            <a:endParaRPr lang="en-US" sz="1800" dirty="0"/>
+            <a:endParaRPr lang="en-US" sz="1700" dirty="0"/>
           </a:p>
         </p:txBody>
       </p:sp>
@@ -9525,8 +9548,8 @@
         </p:nvSpPr>
         <p:spPr>
           <a:xfrm>
-            <a:off x="11521440" y="3886200"/>
-            <a:ext cx="4389120" cy="548640"/>
+            <a:off x="6995160" y="3931920"/>
+            <a:ext cx="4343400" cy="548640"/>
           </a:xfrm>
           <a:prstGeom prst="rect">
             <a:avLst/>
@@ -9567,8 +9590,8 @@
         </p:nvSpPr>
         <p:spPr>
           <a:xfrm>
-            <a:off x="6858000" y="4480560"/>
-            <a:ext cx="4572000" cy="1188720"/>
+            <a:off x="2377440" y="4526280"/>
+            <a:ext cx="4526280" cy="1143000"/>
           </a:xfrm>
           <a:prstGeom prst="rect">
             <a:avLst/>
@@ -9592,8 +9615,8 @@
         </p:nvSpPr>
         <p:spPr>
           <a:xfrm>
-            <a:off x="6949440" y="4572000"/>
-            <a:ext cx="4389120" cy="457200"/>
+            <a:off x="2468880" y="4617720"/>
+            <a:ext cx="4343400" cy="411480"/>
           </a:xfrm>
           <a:prstGeom prst="rect">
             <a:avLst/>
@@ -9609,7 +9632,7 @@
               <a:buNone/>
             </a:pPr>
             <a:r>
-              <a:rPr lang="en-US" sz="1800" b="1" dirty="0">
+              <a:rPr lang="en-US" sz="1700" b="1" dirty="0">
                 <a:solidFill>
                   <a:srgbClr val="E74C3C"/>
                 </a:solidFill>
@@ -9619,7 +9642,7 @@
               </a:rPr>
               <a:t>Erreur α</a:t>
             </a:r>
-            <a:endParaRPr lang="en-US" sz="1800" dirty="0"/>
+            <a:endParaRPr lang="en-US" sz="1700" dirty="0"/>
           </a:p>
         </p:txBody>
       </p:sp>
@@ -9631,8 +9654,8 @@
         </p:nvSpPr>
         <p:spPr>
           <a:xfrm>
-            <a:off x="6949440" y="5074920"/>
-            <a:ext cx="4389120" cy="548640"/>
+            <a:off x="2468880" y="5074920"/>
+            <a:ext cx="4343400" cy="548640"/>
           </a:xfrm>
           <a:prstGeom prst="rect">
             <a:avLst/>
@@ -9673,8 +9696,8 @@
         </p:nvSpPr>
         <p:spPr>
           <a:xfrm>
-            <a:off x="11430000" y="4480560"/>
-            <a:ext cx="4572000" cy="1188720"/>
+            <a:off x="6903720" y="4526280"/>
+            <a:ext cx="4526280" cy="1143000"/>
           </a:xfrm>
           <a:prstGeom prst="rect">
             <a:avLst/>
@@ -9698,8 +9721,8 @@
         </p:nvSpPr>
         <p:spPr>
           <a:xfrm>
-            <a:off x="11521440" y="4572000"/>
-            <a:ext cx="4389120" cy="457200"/>
+            <a:off x="6995160" y="4617720"/>
+            <a:ext cx="4343400" cy="411480"/>
           </a:xfrm>
           <a:prstGeom prst="rect">
             <a:avLst/>
@@ -9715,7 +9738,7 @@
               <a:buNone/>
             </a:pPr>
             <a:r>
-              <a:rPr lang="en-US" sz="1800" b="1" dirty="0">
+              <a:rPr lang="en-US" sz="1700" b="1" dirty="0">
                 <a:solidFill>
                   <a:srgbClr val="0E1729"/>
                 </a:solidFill>
@@ -9725,7 +9748,7 @@
               </a:rPr>
               <a:t>Puissance</a:t>
             </a:r>
-            <a:endParaRPr lang="en-US" sz="1800" dirty="0"/>
+            <a:endParaRPr lang="en-US" sz="1700" dirty="0"/>
           </a:p>
         </p:txBody>
       </p:sp>
@@ -9737,8 +9760,8 @@
         </p:nvSpPr>
         <p:spPr>
           <a:xfrm>
-            <a:off x="11521440" y="5074920"/>
-            <a:ext cx="4389120" cy="548640"/>
+            <a:off x="6995160" y="5074920"/>
+            <a:ext cx="4343400" cy="548640"/>
           </a:xfrm>
           <a:prstGeom prst="rect">
             <a:avLst/>

</xml_diff>

<commit_message>
fix(formations): use flipH/flipV instead of negative dims on line segments
PowerPoint signalait un problème de contenu sur biostat-module-1-fondations.pptx
parce que segment() pouvait générer des shapes ligne avec w ou h négatifs
quand le segment allait vers la gauche ou vers le haut. PPTX/OOXML attend
des dimensions positives et utilise flipH/flipV pour indiquer la direction.

- segment() utilise désormais Math.min/Math.abs + flipH/flipV
- Garde-fou : dimension minimale 0.005 pour éviter les lignes nulles

Régénération des 4 modules. Plus d'avertissement 'PowerPoint a détecté
un problème'.
</commit_message>
<xml_diff>
--- a/formations/output/biostat-module-1-fondations.pptx
+++ b/formations/output/biostat-module-1-fondations.pptx
@@ -6774,7 +6774,7 @@
         <p:spPr>
           <a:xfrm>
             <a:off x="9660636" y="3360420"/>
-            <a:ext cx="0" cy="274320"/>
+            <a:ext cx="4572" cy="274320"/>
           </a:xfrm>
           <a:prstGeom prst="line">
             <a:avLst/>
@@ -6818,9 +6818,9 @@
           <p:nvPr/>
         </p:nvSpPr>
         <p:spPr>
-          <a:xfrm>
-            <a:off x="9733788" y="3561588"/>
-            <a:ext cx="-73152" cy="73152"/>
+          <a:xfrm flipH="1">
+            <a:off x="9660636" y="3561588"/>
+            <a:ext cx="73152" cy="73152"/>
           </a:xfrm>
           <a:prstGeom prst="line">
             <a:avLst/>
@@ -6909,7 +6909,7 @@
         <p:spPr>
           <a:xfrm>
             <a:off x="9660636" y="3931920"/>
-            <a:ext cx="0" cy="274320"/>
+            <a:ext cx="4572" cy="274320"/>
           </a:xfrm>
           <a:prstGeom prst="line">
             <a:avLst/>
@@ -6953,9 +6953,9 @@
           <p:nvPr/>
         </p:nvSpPr>
         <p:spPr>
-          <a:xfrm>
-            <a:off x="9733788" y="4133088"/>
-            <a:ext cx="-73152" cy="73152"/>
+          <a:xfrm flipH="1">
+            <a:off x="9660636" y="4133088"/>
+            <a:ext cx="73152" cy="73152"/>
           </a:xfrm>
           <a:prstGeom prst="line">
             <a:avLst/>
@@ -7044,7 +7044,7 @@
         <p:spPr>
           <a:xfrm>
             <a:off x="9660636" y="4503420"/>
-            <a:ext cx="0" cy="274320"/>
+            <a:ext cx="4572" cy="274320"/>
           </a:xfrm>
           <a:prstGeom prst="line">
             <a:avLst/>
@@ -7088,9 +7088,9 @@
           <p:nvPr/>
         </p:nvSpPr>
         <p:spPr>
-          <a:xfrm>
-            <a:off x="9733788" y="4704588"/>
-            <a:ext cx="-73152" cy="73152"/>
+          <a:xfrm flipH="1">
+            <a:off x="9660636" y="4704588"/>
+            <a:ext cx="73152" cy="73152"/>
           </a:xfrm>
           <a:prstGeom prst="line">
             <a:avLst/>
@@ -7179,7 +7179,7 @@
         <p:spPr>
           <a:xfrm>
             <a:off x="9660636" y="5074920"/>
-            <a:ext cx="0" cy="274320"/>
+            <a:ext cx="4572" cy="274320"/>
           </a:xfrm>
           <a:prstGeom prst="line">
             <a:avLst/>
@@ -7223,9 +7223,9 @@
           <p:nvPr/>
         </p:nvSpPr>
         <p:spPr>
-          <a:xfrm>
-            <a:off x="9733788" y="5276088"/>
-            <a:ext cx="-73152" cy="73152"/>
+          <a:xfrm flipH="1">
+            <a:off x="9660636" y="5276088"/>
+            <a:ext cx="73152" cy="73152"/>
           </a:xfrm>
           <a:prstGeom prst="line">
             <a:avLst/>
@@ -7353,7 +7353,7 @@
         <p:spPr>
           <a:xfrm>
             <a:off x="9660636" y="5646420"/>
-            <a:ext cx="0" cy="274320"/>
+            <a:ext cx="4572" cy="274320"/>
           </a:xfrm>
           <a:prstGeom prst="line">
             <a:avLst/>
@@ -7397,9 +7397,9 @@
           <p:nvPr/>
         </p:nvSpPr>
         <p:spPr>
-          <a:xfrm>
-            <a:off x="9733788" y="5847588"/>
-            <a:ext cx="-73152" cy="73152"/>
+          <a:xfrm flipH="1">
+            <a:off x="9660636" y="5847588"/>
+            <a:ext cx="73152" cy="73152"/>
           </a:xfrm>
           <a:prstGeom prst="line">
             <a:avLst/>
@@ -9421,7 +9421,7 @@
         <p:spPr>
           <a:xfrm>
             <a:off x="2684678" y="4274820"/>
-            <a:ext cx="182880" cy="0"/>
+            <a:ext cx="182880" cy="4572"/>
           </a:xfrm>
           <a:prstGeom prst="line">
             <a:avLst/>
@@ -9465,9 +9465,9 @@
           <p:nvPr/>
         </p:nvSpPr>
         <p:spPr>
-          <a:xfrm>
-            <a:off x="2794406" y="4347972"/>
-            <a:ext cx="73152" cy="-73152"/>
+          <a:xfrm flipV="1">
+            <a:off x="2794406" y="4274820"/>
+            <a:ext cx="73152" cy="73152"/>
           </a:xfrm>
           <a:prstGeom prst="line">
             <a:avLst/>
@@ -9641,7 +9641,7 @@
         <p:spPr>
           <a:xfrm>
             <a:off x="4957877" y="4274820"/>
-            <a:ext cx="182880" cy="0"/>
+            <a:ext cx="182880" cy="4572"/>
           </a:xfrm>
           <a:prstGeom prst="line">
             <a:avLst/>
@@ -9685,9 +9685,9 @@
           <p:nvPr/>
         </p:nvSpPr>
         <p:spPr>
-          <a:xfrm>
-            <a:off x="5067605" y="4347972"/>
-            <a:ext cx="73152" cy="-73152"/>
+          <a:xfrm flipV="1">
+            <a:off x="5067605" y="4274820"/>
+            <a:ext cx="73152" cy="73152"/>
           </a:xfrm>
           <a:prstGeom prst="line">
             <a:avLst/>
@@ -9861,7 +9861,7 @@
         <p:spPr>
           <a:xfrm>
             <a:off x="7231075" y="4274820"/>
-            <a:ext cx="182880" cy="0"/>
+            <a:ext cx="182880" cy="4572"/>
           </a:xfrm>
           <a:prstGeom prst="line">
             <a:avLst/>
@@ -9905,9 +9905,9 @@
           <p:nvPr/>
         </p:nvSpPr>
         <p:spPr>
-          <a:xfrm>
-            <a:off x="7340803" y="4347972"/>
-            <a:ext cx="73152" cy="-73152"/>
+          <a:xfrm flipV="1">
+            <a:off x="7340803" y="4274820"/>
+            <a:ext cx="73152" cy="73152"/>
           </a:xfrm>
           <a:prstGeom prst="line">
             <a:avLst/>
@@ -10081,7 +10081,7 @@
         <p:spPr>
           <a:xfrm>
             <a:off x="9504274" y="4274820"/>
-            <a:ext cx="182880" cy="0"/>
+            <a:ext cx="182880" cy="4572"/>
           </a:xfrm>
           <a:prstGeom prst="line">
             <a:avLst/>
@@ -10125,9 +10125,9 @@
           <p:nvPr/>
         </p:nvSpPr>
         <p:spPr>
-          <a:xfrm>
-            <a:off x="9614002" y="4347972"/>
-            <a:ext cx="73152" cy="-73152"/>
+          <a:xfrm flipV="1">
+            <a:off x="9614002" y="4274820"/>
+            <a:ext cx="73152" cy="73152"/>
           </a:xfrm>
           <a:prstGeom prst="line">
             <a:avLst/>
@@ -14462,9 +14462,9 @@
           <p:nvPr/>
         </p:nvSpPr>
         <p:spPr>
-          <a:xfrm>
-            <a:off x="868680" y="5664509"/>
-            <a:ext cx="128016" cy="-3898"/>
+          <a:xfrm flipV="1">
+            <a:off x="868680" y="5660612"/>
+            <a:ext cx="128016" cy="4572"/>
           </a:xfrm>
           <a:prstGeom prst="line">
             <a:avLst/>
@@ -14485,9 +14485,9 @@
           <p:nvPr/>
         </p:nvSpPr>
         <p:spPr>
-          <a:xfrm>
-            <a:off x="996696" y="5660612"/>
-            <a:ext cx="128016" cy="-6607"/>
+          <a:xfrm flipV="1">
+            <a:off x="996696" y="5654005"/>
+            <a:ext cx="128016" cy="6607"/>
           </a:xfrm>
           <a:prstGeom prst="line">
             <a:avLst/>
@@ -14508,9 +14508,9 @@
           <p:nvPr/>
         </p:nvSpPr>
         <p:spPr>
-          <a:xfrm>
-            <a:off x="1124712" y="5654005"/>
-            <a:ext cx="128016" cy="-10831"/>
+          <a:xfrm flipV="1">
+            <a:off x="1124712" y="5643174"/>
+            <a:ext cx="128016" cy="10831"/>
           </a:xfrm>
           <a:prstGeom prst="line">
             <a:avLst/>
@@ -14531,9 +14531,9 @@
           <p:nvPr/>
         </p:nvSpPr>
         <p:spPr>
-          <a:xfrm>
-            <a:off x="1252728" y="5643174"/>
-            <a:ext cx="128016" cy="-17165"/>
+          <a:xfrm flipV="1">
+            <a:off x="1252728" y="5626010"/>
+            <a:ext cx="128016" cy="17165"/>
           </a:xfrm>
           <a:prstGeom prst="line">
             <a:avLst/>
@@ -14554,9 +14554,9 @@
           <p:nvPr/>
         </p:nvSpPr>
         <p:spPr>
-          <a:xfrm>
-            <a:off x="1380744" y="5626010"/>
-            <a:ext cx="128016" cy="-26287"/>
+          <a:xfrm flipV="1">
+            <a:off x="1380744" y="5599722"/>
+            <a:ext cx="128016" cy="26287"/>
           </a:xfrm>
           <a:prstGeom prst="line">
             <a:avLst/>
@@ -14577,9 +14577,9 @@
           <p:nvPr/>
         </p:nvSpPr>
         <p:spPr>
-          <a:xfrm>
-            <a:off x="1508760" y="5599722"/>
-            <a:ext cx="128016" cy="-38885"/>
+          <a:xfrm flipV="1">
+            <a:off x="1508760" y="5560838"/>
+            <a:ext cx="128016" cy="38885"/>
           </a:xfrm>
           <a:prstGeom prst="line">
             <a:avLst/>
@@ -14600,9 +14600,9 @@
           <p:nvPr/>
         </p:nvSpPr>
         <p:spPr>
-          <a:xfrm>
-            <a:off x="1636776" y="5560838"/>
-            <a:ext cx="128016" cy="-55523"/>
+          <a:xfrm flipV="1">
+            <a:off x="1636776" y="5505315"/>
+            <a:ext cx="128016" cy="55523"/>
           </a:xfrm>
           <a:prstGeom prst="line">
             <a:avLst/>
@@ -14623,9 +14623,9 @@
           <p:nvPr/>
         </p:nvSpPr>
         <p:spPr>
-          <a:xfrm>
-            <a:off x="1764792" y="5505315"/>
-            <a:ext cx="128016" cy="-76474"/>
+          <a:xfrm flipV="1">
+            <a:off x="1764792" y="5428841"/>
+            <a:ext cx="128016" cy="76474"/>
           </a:xfrm>
           <a:prstGeom prst="line">
             <a:avLst/>
@@ -14646,9 +14646,9 @@
           <p:nvPr/>
         </p:nvSpPr>
         <p:spPr>
-          <a:xfrm>
-            <a:off x="1892808" y="5428841"/>
-            <a:ext cx="128016" cy="-101507"/>
+          <a:xfrm flipV="1">
+            <a:off x="1892808" y="5327333"/>
+            <a:ext cx="128016" cy="101507"/>
           </a:xfrm>
           <a:prstGeom prst="line">
             <a:avLst/>
@@ -14669,9 +14669,9 @@
           <p:nvPr/>
         </p:nvSpPr>
         <p:spPr>
-          <a:xfrm>
-            <a:off x="2020824" y="5327333"/>
-            <a:ext cx="128016" cy="-129694"/>
+          <a:xfrm flipV="1">
+            <a:off x="2020824" y="5197639"/>
+            <a:ext cx="128016" cy="129694"/>
           </a:xfrm>
           <a:prstGeom prst="line">
             <a:avLst/>
@@ -14692,9 +14692,9 @@
           <p:nvPr/>
         </p:nvSpPr>
         <p:spPr>
-          <a:xfrm>
-            <a:off x="2148840" y="5197639"/>
-            <a:ext cx="128016" cy="-159264"/>
+          <a:xfrm flipV="1">
+            <a:off x="2148840" y="5038375"/>
+            <a:ext cx="128016" cy="159264"/>
           </a:xfrm>
           <a:prstGeom prst="line">
             <a:avLst/>
@@ -14715,9 +14715,9 @@
           <p:nvPr/>
         </p:nvSpPr>
         <p:spPr>
-          <a:xfrm>
-            <a:off x="2276856" y="5038375"/>
-            <a:ext cx="128016" cy="-187590"/>
+          <a:xfrm flipV="1">
+            <a:off x="2276856" y="4850785"/>
+            <a:ext cx="128016" cy="187590"/>
           </a:xfrm>
           <a:prstGeom prst="line">
             <a:avLst/>
@@ -14738,9 +14738,9 @@
           <p:nvPr/>
         </p:nvSpPr>
         <p:spPr>
-          <a:xfrm>
-            <a:off x="2404872" y="4850785"/>
-            <a:ext cx="128016" cy="-211341"/>
+          <a:xfrm flipV="1">
+            <a:off x="2404872" y="4639444"/>
+            <a:ext cx="128016" cy="211341"/>
           </a:xfrm>
           <a:prstGeom prst="line">
             <a:avLst/>
@@ -14761,9 +14761,9 @@
           <p:nvPr/>
         </p:nvSpPr>
         <p:spPr>
-          <a:xfrm>
-            <a:off x="2532888" y="4639444"/>
-            <a:ext cx="128016" cy="-226830"/>
+          <a:xfrm flipV="1">
+            <a:off x="2532888" y="4412614"/>
+            <a:ext cx="128016" cy="226830"/>
           </a:xfrm>
           <a:prstGeom prst="line">
             <a:avLst/>
@@ -14784,9 +14784,9 @@
           <p:nvPr/>
         </p:nvSpPr>
         <p:spPr>
-          <a:xfrm>
-            <a:off x="2660904" y="4412614"/>
-            <a:ext cx="128016" cy="-230541"/>
+          <a:xfrm flipV="1">
+            <a:off x="2660904" y="4182074"/>
+            <a:ext cx="128016" cy="230541"/>
           </a:xfrm>
           <a:prstGeom prst="line">
             <a:avLst/>
@@ -14807,9 +14807,9 @@
           <p:nvPr/>
         </p:nvSpPr>
         <p:spPr>
-          <a:xfrm>
-            <a:off x="2788920" y="4182074"/>
-            <a:ext cx="128016" cy="-219750"/>
+          <a:xfrm flipV="1">
+            <a:off x="2788920" y="3962324"/>
+            <a:ext cx="128016" cy="219750"/>
           </a:xfrm>
           <a:prstGeom prst="line">
             <a:avLst/>
@@ -14830,9 +14830,9 @@
           <p:nvPr/>
         </p:nvSpPr>
         <p:spPr>
-          <a:xfrm>
-            <a:off x="2916936" y="3962324"/>
-            <a:ext cx="128016" cy="-193130"/>
+          <a:xfrm flipV="1">
+            <a:off x="2916936" y="3769193"/>
+            <a:ext cx="128016" cy="193130"/>
           </a:xfrm>
           <a:prstGeom prst="line">
             <a:avLst/>
@@ -14853,9 +14853,9 @@
           <p:nvPr/>
         </p:nvSpPr>
         <p:spPr>
-          <a:xfrm>
-            <a:off x="3044952" y="3769193"/>
-            <a:ext cx="128016" cy="-151189"/>
+          <a:xfrm flipV="1">
+            <a:off x="3044952" y="3618004"/>
+            <a:ext cx="128016" cy="151189"/>
           </a:xfrm>
           <a:prstGeom prst="line">
             <a:avLst/>
@@ -14876,9 +14876,9 @@
           <p:nvPr/>
         </p:nvSpPr>
         <p:spPr>
-          <a:xfrm>
-            <a:off x="3172968" y="3618004"/>
-            <a:ext cx="128016" cy="-96428"/>
+          <a:xfrm flipV="1">
+            <a:off x="3172968" y="3521576"/>
+            <a:ext cx="128016" cy="96428"/>
           </a:xfrm>
           <a:prstGeom prst="line">
             <a:avLst/>
@@ -14899,9 +14899,9 @@
           <p:nvPr/>
         </p:nvSpPr>
         <p:spPr>
-          <a:xfrm>
-            <a:off x="3300984" y="3521576"/>
-            <a:ext cx="128016" cy="-33140"/>
+          <a:xfrm flipV="1">
+            <a:off x="3300984" y="3488436"/>
+            <a:ext cx="128016" cy="33140"/>
           </a:xfrm>
           <a:prstGeom prst="line">
             <a:avLst/>
@@ -15361,7 +15361,7 @@
         <p:spPr>
           <a:xfrm>
             <a:off x="5861304" y="5660612"/>
-            <a:ext cx="128016" cy="3898"/>
+            <a:ext cx="128016" cy="4572"/>
           </a:xfrm>
           <a:prstGeom prst="line">
             <a:avLst/>
@@ -15553,9 +15553,9 @@
           <p:nvPr/>
         </p:nvSpPr>
         <p:spPr>
-          <a:xfrm>
-            <a:off x="6492240" y="5664509"/>
-            <a:ext cx="128016" cy="-3898"/>
+          <a:xfrm flipV="1">
+            <a:off x="6492240" y="5660612"/>
+            <a:ext cx="128016" cy="4572"/>
           </a:xfrm>
           <a:prstGeom prst="line">
             <a:avLst/>
@@ -15576,9 +15576,9 @@
           <p:nvPr/>
         </p:nvSpPr>
         <p:spPr>
-          <a:xfrm>
-            <a:off x="6620256" y="5660612"/>
-            <a:ext cx="128016" cy="-6607"/>
+          <a:xfrm flipV="1">
+            <a:off x="6620256" y="5654005"/>
+            <a:ext cx="128016" cy="6607"/>
           </a:xfrm>
           <a:prstGeom prst="line">
             <a:avLst/>
@@ -15599,9 +15599,9 @@
           <p:nvPr/>
         </p:nvSpPr>
         <p:spPr>
-          <a:xfrm>
-            <a:off x="6748272" y="5654005"/>
-            <a:ext cx="128016" cy="-10831"/>
+          <a:xfrm flipV="1">
+            <a:off x="6748272" y="5643174"/>
+            <a:ext cx="128016" cy="10831"/>
           </a:xfrm>
           <a:prstGeom prst="line">
             <a:avLst/>
@@ -15622,9 +15622,9 @@
           <p:nvPr/>
         </p:nvSpPr>
         <p:spPr>
-          <a:xfrm>
-            <a:off x="6876288" y="5643174"/>
-            <a:ext cx="128016" cy="-17165"/>
+          <a:xfrm flipV="1">
+            <a:off x="6876288" y="5626010"/>
+            <a:ext cx="128016" cy="17165"/>
           </a:xfrm>
           <a:prstGeom prst="line">
             <a:avLst/>
@@ -15645,9 +15645,9 @@
           <p:nvPr/>
         </p:nvSpPr>
         <p:spPr>
-          <a:xfrm>
-            <a:off x="7004304" y="5626010"/>
-            <a:ext cx="128016" cy="-26287"/>
+          <a:xfrm flipV="1">
+            <a:off x="7004304" y="5599722"/>
+            <a:ext cx="128016" cy="26287"/>
           </a:xfrm>
           <a:prstGeom prst="line">
             <a:avLst/>
@@ -15668,9 +15668,9 @@
           <p:nvPr/>
         </p:nvSpPr>
         <p:spPr>
-          <a:xfrm>
-            <a:off x="7132320" y="5599722"/>
-            <a:ext cx="128016" cy="-38885"/>
+          <a:xfrm flipV="1">
+            <a:off x="7132320" y="5560838"/>
+            <a:ext cx="128016" cy="38885"/>
           </a:xfrm>
           <a:prstGeom prst="line">
             <a:avLst/>
@@ -15691,9 +15691,9 @@
           <p:nvPr/>
         </p:nvSpPr>
         <p:spPr>
-          <a:xfrm>
-            <a:off x="7260336" y="5560838"/>
-            <a:ext cx="128016" cy="-55523"/>
+          <a:xfrm flipV="1">
+            <a:off x="7260336" y="5505315"/>
+            <a:ext cx="128016" cy="55523"/>
           </a:xfrm>
           <a:prstGeom prst="line">
             <a:avLst/>
@@ -15714,9 +15714,9 @@
           <p:nvPr/>
         </p:nvSpPr>
         <p:spPr>
-          <a:xfrm>
-            <a:off x="7388352" y="5505315"/>
-            <a:ext cx="128016" cy="-76474"/>
+          <a:xfrm flipV="1">
+            <a:off x="7388352" y="5428841"/>
+            <a:ext cx="128016" cy="76474"/>
           </a:xfrm>
           <a:prstGeom prst="line">
             <a:avLst/>
@@ -15737,9 +15737,9 @@
           <p:nvPr/>
         </p:nvSpPr>
         <p:spPr>
-          <a:xfrm>
-            <a:off x="7516368" y="5428841"/>
-            <a:ext cx="128016" cy="-101507"/>
+          <a:xfrm flipV="1">
+            <a:off x="7516368" y="5327333"/>
+            <a:ext cx="128016" cy="101507"/>
           </a:xfrm>
           <a:prstGeom prst="line">
             <a:avLst/>
@@ -15760,9 +15760,9 @@
           <p:nvPr/>
         </p:nvSpPr>
         <p:spPr>
-          <a:xfrm>
-            <a:off x="7644384" y="5327333"/>
-            <a:ext cx="128016" cy="-129694"/>
+          <a:xfrm flipV="1">
+            <a:off x="7644384" y="5197639"/>
+            <a:ext cx="128016" cy="129694"/>
           </a:xfrm>
           <a:prstGeom prst="line">
             <a:avLst/>
@@ -15783,9 +15783,9 @@
           <p:nvPr/>
         </p:nvSpPr>
         <p:spPr>
-          <a:xfrm>
-            <a:off x="7772400" y="5197639"/>
-            <a:ext cx="128016" cy="-159264"/>
+          <a:xfrm flipV="1">
+            <a:off x="7772400" y="5038375"/>
+            <a:ext cx="128016" cy="159264"/>
           </a:xfrm>
           <a:prstGeom prst="line">
             <a:avLst/>
@@ -15806,9 +15806,9 @@
           <p:nvPr/>
         </p:nvSpPr>
         <p:spPr>
-          <a:xfrm>
-            <a:off x="7900416" y="5038375"/>
-            <a:ext cx="128016" cy="-187590"/>
+          <a:xfrm flipV="1">
+            <a:off x="7900416" y="4850785"/>
+            <a:ext cx="128016" cy="187590"/>
           </a:xfrm>
           <a:prstGeom prst="line">
             <a:avLst/>
@@ -15829,9 +15829,9 @@
           <p:nvPr/>
         </p:nvSpPr>
         <p:spPr>
-          <a:xfrm>
-            <a:off x="8028432" y="4850785"/>
-            <a:ext cx="128016" cy="-211341"/>
+          <a:xfrm flipV="1">
+            <a:off x="8028432" y="4639444"/>
+            <a:ext cx="128016" cy="211341"/>
           </a:xfrm>
           <a:prstGeom prst="line">
             <a:avLst/>
@@ -15852,9 +15852,9 @@
           <p:nvPr/>
         </p:nvSpPr>
         <p:spPr>
-          <a:xfrm>
-            <a:off x="8156448" y="4639444"/>
-            <a:ext cx="128016" cy="-226830"/>
+          <a:xfrm flipV="1">
+            <a:off x="8156448" y="4412614"/>
+            <a:ext cx="128016" cy="226830"/>
           </a:xfrm>
           <a:prstGeom prst="line">
             <a:avLst/>
@@ -15875,9 +15875,9 @@
           <p:nvPr/>
         </p:nvSpPr>
         <p:spPr>
-          <a:xfrm>
-            <a:off x="8284464" y="4412614"/>
-            <a:ext cx="128016" cy="-230541"/>
+          <a:xfrm flipV="1">
+            <a:off x="8284464" y="4182074"/>
+            <a:ext cx="128016" cy="230541"/>
           </a:xfrm>
           <a:prstGeom prst="line">
             <a:avLst/>
@@ -15898,9 +15898,9 @@
           <p:nvPr/>
         </p:nvSpPr>
         <p:spPr>
-          <a:xfrm>
-            <a:off x="8412480" y="4182074"/>
-            <a:ext cx="128016" cy="-219750"/>
+          <a:xfrm flipV="1">
+            <a:off x="8412480" y="3962324"/>
+            <a:ext cx="128016" cy="219750"/>
           </a:xfrm>
           <a:prstGeom prst="line">
             <a:avLst/>
@@ -15921,9 +15921,9 @@
           <p:nvPr/>
         </p:nvSpPr>
         <p:spPr>
-          <a:xfrm>
-            <a:off x="8540496" y="3962324"/>
-            <a:ext cx="128016" cy="-193130"/>
+          <a:xfrm flipV="1">
+            <a:off x="8540496" y="3769193"/>
+            <a:ext cx="128016" cy="193130"/>
           </a:xfrm>
           <a:prstGeom prst="line">
             <a:avLst/>
@@ -15944,9 +15944,9 @@
           <p:nvPr/>
         </p:nvSpPr>
         <p:spPr>
-          <a:xfrm>
-            <a:off x="8668512" y="3769193"/>
-            <a:ext cx="128016" cy="-151189"/>
+          <a:xfrm flipV="1">
+            <a:off x="8668512" y="3618004"/>
+            <a:ext cx="128016" cy="151189"/>
           </a:xfrm>
           <a:prstGeom prst="line">
             <a:avLst/>
@@ -15967,9 +15967,9 @@
           <p:nvPr/>
         </p:nvSpPr>
         <p:spPr>
-          <a:xfrm>
-            <a:off x="8796528" y="3618004"/>
-            <a:ext cx="128016" cy="-96428"/>
+          <a:xfrm flipV="1">
+            <a:off x="8796528" y="3521576"/>
+            <a:ext cx="128016" cy="96428"/>
           </a:xfrm>
           <a:prstGeom prst="line">
             <a:avLst/>
@@ -15990,9 +15990,9 @@
           <p:nvPr/>
         </p:nvSpPr>
         <p:spPr>
-          <a:xfrm>
-            <a:off x="8924544" y="3521576"/>
-            <a:ext cx="128016" cy="-33140"/>
+          <a:xfrm flipV="1">
+            <a:off x="8924544" y="3488436"/>
+            <a:ext cx="128016" cy="33140"/>
           </a:xfrm>
           <a:prstGeom prst="line">
             <a:avLst/>
@@ -16452,7 +16452,7 @@
         <p:spPr>
           <a:xfrm>
             <a:off x="11484864" y="5660612"/>
-            <a:ext cx="128016" cy="3898"/>
+            <a:ext cx="128016" cy="4572"/>
           </a:xfrm>
           <a:prstGeom prst="line">
             <a:avLst/>
@@ -16916,9 +16916,9 @@
           <p:nvPr/>
         </p:nvSpPr>
         <p:spPr>
-          <a:xfrm>
-            <a:off x="868680" y="5710950"/>
-            <a:ext cx="126873" cy="-3309"/>
+          <a:xfrm flipV="1">
+            <a:off x="868680" y="5707640"/>
+            <a:ext cx="126873" cy="4572"/>
           </a:xfrm>
           <a:prstGeom prst="line">
             <a:avLst/>
@@ -16939,9 +16939,9 @@
           <p:nvPr/>
         </p:nvSpPr>
         <p:spPr>
-          <a:xfrm>
-            <a:off x="995553" y="5707640"/>
-            <a:ext cx="126873" cy="-5610"/>
+          <a:xfrm flipV="1">
+            <a:off x="995553" y="5702031"/>
+            <a:ext cx="126873" cy="5610"/>
           </a:xfrm>
           <a:prstGeom prst="line">
             <a:avLst/>
@@ -16962,9 +16962,9 @@
           <p:nvPr/>
         </p:nvSpPr>
         <p:spPr>
-          <a:xfrm>
-            <a:off x="1122426" y="5702031"/>
-            <a:ext cx="126873" cy="-9196"/>
+          <a:xfrm flipV="1">
+            <a:off x="1122426" y="5692835"/>
+            <a:ext cx="126873" cy="9196"/>
           </a:xfrm>
           <a:prstGeom prst="line">
             <a:avLst/>
@@ -16985,9 +16985,9 @@
           <p:nvPr/>
         </p:nvSpPr>
         <p:spPr>
-          <a:xfrm>
-            <a:off x="1249299" y="5692835"/>
-            <a:ext cx="126873" cy="-14574"/>
+          <a:xfrm flipV="1">
+            <a:off x="1249299" y="5678261"/>
+            <a:ext cx="126873" cy="14574"/>
           </a:xfrm>
           <a:prstGeom prst="line">
             <a:avLst/>
@@ -17008,9 +17008,9 @@
           <p:nvPr/>
         </p:nvSpPr>
         <p:spPr>
-          <a:xfrm>
-            <a:off x="1376172" y="5678261"/>
-            <a:ext cx="126873" cy="-22319"/>
+          <a:xfrm flipV="1">
+            <a:off x="1376172" y="5655942"/>
+            <a:ext cx="126873" cy="22319"/>
           </a:xfrm>
           <a:prstGeom prst="line">
             <a:avLst/>
@@ -17031,9 +17031,9 @@
           <p:nvPr/>
         </p:nvSpPr>
         <p:spPr>
-          <a:xfrm>
-            <a:off x="1503045" y="5655942"/>
-            <a:ext cx="126873" cy="-33015"/>
+          <a:xfrm flipV="1">
+            <a:off x="1503045" y="5622926"/>
+            <a:ext cx="126873" cy="33015"/>
           </a:xfrm>
           <a:prstGeom prst="line">
             <a:avLst/>
@@ -17054,9 +17054,9 @@
           <p:nvPr/>
         </p:nvSpPr>
         <p:spPr>
-          <a:xfrm>
-            <a:off x="1629918" y="5622926"/>
-            <a:ext cx="126873" cy="-47142"/>
+          <a:xfrm flipV="1">
+            <a:off x="1629918" y="5575784"/>
+            <a:ext cx="126873" cy="47142"/>
           </a:xfrm>
           <a:prstGeom prst="line">
             <a:avLst/>
@@ -17077,9 +17077,9 @@
           <p:nvPr/>
         </p:nvSpPr>
         <p:spPr>
-          <a:xfrm>
-            <a:off x="1756791" y="5575784"/>
-            <a:ext cx="126873" cy="-64931"/>
+          <a:xfrm flipV="1">
+            <a:off x="1756791" y="5510854"/>
+            <a:ext cx="126873" cy="64931"/>
           </a:xfrm>
           <a:prstGeom prst="line">
             <a:avLst/>
@@ -17100,9 +17100,9 @@
           <p:nvPr/>
         </p:nvSpPr>
         <p:spPr>
-          <a:xfrm>
-            <a:off x="1883664" y="5510854"/>
-            <a:ext cx="126873" cy="-86186"/>
+          <a:xfrm flipV="1">
+            <a:off x="1883664" y="5424668"/>
+            <a:ext cx="126873" cy="86186"/>
           </a:xfrm>
           <a:prstGeom prst="line">
             <a:avLst/>
@@ -17123,9 +17123,9 @@
           <p:nvPr/>
         </p:nvSpPr>
         <p:spPr>
-          <a:xfrm>
-            <a:off x="2010537" y="5424668"/>
-            <a:ext cx="126873" cy="-110117"/>
+          <a:xfrm flipV="1">
+            <a:off x="2010537" y="5314550"/>
+            <a:ext cx="126873" cy="110117"/>
           </a:xfrm>
           <a:prstGeom prst="line">
             <a:avLst/>
@@ -17146,9 +17146,9 @@
           <p:nvPr/>
         </p:nvSpPr>
         <p:spPr>
-          <a:xfrm>
-            <a:off x="2137410" y="5314550"/>
-            <a:ext cx="126873" cy="-135224"/>
+          <a:xfrm flipV="1">
+            <a:off x="2137410" y="5179326"/>
+            <a:ext cx="126873" cy="135224"/>
           </a:xfrm>
           <a:prstGeom prst="line">
             <a:avLst/>
@@ -17169,9 +17169,9 @@
           <p:nvPr/>
         </p:nvSpPr>
         <p:spPr>
-          <a:xfrm>
-            <a:off x="2264283" y="5179326"/>
-            <a:ext cx="126873" cy="-159275"/>
+          <a:xfrm flipV="1">
+            <a:off x="2264283" y="5020051"/>
+            <a:ext cx="126873" cy="159275"/>
           </a:xfrm>
           <a:prstGeom prst="line">
             <a:avLst/>
@@ -17192,9 +17192,9 @@
           <p:nvPr/>
         </p:nvSpPr>
         <p:spPr>
-          <a:xfrm>
-            <a:off x="2391156" y="5020051"/>
-            <a:ext cx="126873" cy="-179440"/>
+          <a:xfrm flipV="1">
+            <a:off x="2391156" y="4840611"/>
+            <a:ext cx="126873" cy="179440"/>
           </a:xfrm>
           <a:prstGeom prst="line">
             <a:avLst/>
@@ -17215,9 +17215,9 @@
           <p:nvPr/>
         </p:nvSpPr>
         <p:spPr>
-          <a:xfrm>
-            <a:off x="2518029" y="4840611"/>
-            <a:ext cx="126873" cy="-192591"/>
+          <a:xfrm flipV="1">
+            <a:off x="2518029" y="4648020"/>
+            <a:ext cx="126873" cy="192591"/>
           </a:xfrm>
           <a:prstGeom prst="line">
             <a:avLst/>
@@ -17238,9 +17238,9 @@
           <p:nvPr/>
         </p:nvSpPr>
         <p:spPr>
-          <a:xfrm>
-            <a:off x="2644902" y="4648020"/>
-            <a:ext cx="126873" cy="-195742"/>
+          <a:xfrm flipV="1">
+            <a:off x="2644902" y="4452278"/>
+            <a:ext cx="126873" cy="195742"/>
           </a:xfrm>
           <a:prstGeom prst="line">
             <a:avLst/>
@@ -17261,9 +17261,9 @@
           <p:nvPr/>
         </p:nvSpPr>
         <p:spPr>
-          <a:xfrm>
-            <a:off x="2771775" y="4452278"/>
-            <a:ext cx="126873" cy="-186580"/>
+          <a:xfrm flipV="1">
+            <a:off x="2771775" y="4265697"/>
+            <a:ext cx="126873" cy="186580"/>
           </a:xfrm>
           <a:prstGeom prst="line">
             <a:avLst/>
@@ -17284,9 +17284,9 @@
           <p:nvPr/>
         </p:nvSpPr>
         <p:spPr>
-          <a:xfrm>
-            <a:off x="2898648" y="4265697"/>
-            <a:ext cx="126873" cy="-163978"/>
+          <a:xfrm flipV="1">
+            <a:off x="2898648" y="4101719"/>
+            <a:ext cx="126873" cy="163978"/>
           </a:xfrm>
           <a:prstGeom prst="line">
             <a:avLst/>
@@ -17307,9 +17307,9 @@
           <p:nvPr/>
         </p:nvSpPr>
         <p:spPr>
-          <a:xfrm>
-            <a:off x="3025521" y="4101719"/>
-            <a:ext cx="126873" cy="-128368"/>
+          <a:xfrm flipV="1">
+            <a:off x="3025521" y="3973351"/>
+            <a:ext cx="126873" cy="128368"/>
           </a:xfrm>
           <a:prstGeom prst="line">
             <a:avLst/>
@@ -17330,9 +17330,9 @@
           <p:nvPr/>
         </p:nvSpPr>
         <p:spPr>
-          <a:xfrm>
-            <a:off x="3152394" y="3973351"/>
-            <a:ext cx="126873" cy="-81873"/>
+          <a:xfrm flipV="1">
+            <a:off x="3152394" y="3891478"/>
+            <a:ext cx="126873" cy="81873"/>
           </a:xfrm>
           <a:prstGeom prst="line">
             <a:avLst/>
@@ -17353,9 +17353,9 @@
           <p:nvPr/>
         </p:nvSpPr>
         <p:spPr>
-          <a:xfrm>
-            <a:off x="3279267" y="3891478"/>
-            <a:ext cx="126873" cy="-28138"/>
+          <a:xfrm flipV="1">
+            <a:off x="3279267" y="3863340"/>
+            <a:ext cx="126873" cy="28138"/>
           </a:xfrm>
           <a:prstGeom prst="line">
             <a:avLst/>
@@ -17815,7 +17815,7 @@
         <p:spPr>
           <a:xfrm>
             <a:off x="5816727" y="5707640"/>
-            <a:ext cx="126873" cy="3309"/>
+            <a:ext cx="126873" cy="4572"/>
           </a:xfrm>
           <a:prstGeom prst="line">
             <a:avLst/>
@@ -18473,9 +18473,9 @@
           <p:nvPr/>
         </p:nvSpPr>
         <p:spPr>
-          <a:xfrm>
-            <a:off x="868680" y="4934070"/>
-            <a:ext cx="123602" cy="-3015"/>
+          <a:xfrm flipV="1">
+            <a:off x="868680" y="4931054"/>
+            <a:ext cx="123602" cy="4572"/>
           </a:xfrm>
           <a:prstGeom prst="line">
             <a:avLst/>
@@ -18496,9 +18496,9 @@
           <p:nvPr/>
         </p:nvSpPr>
         <p:spPr>
-          <a:xfrm>
-            <a:off x="992282" y="4931054"/>
-            <a:ext cx="123602" cy="-5111"/>
+          <a:xfrm flipV="1">
+            <a:off x="992282" y="4925943"/>
+            <a:ext cx="123602" cy="5111"/>
           </a:xfrm>
           <a:prstGeom prst="line">
             <a:avLst/>
@@ -18519,9 +18519,9 @@
           <p:nvPr/>
         </p:nvSpPr>
         <p:spPr>
-          <a:xfrm>
-            <a:off x="1115883" y="4925943"/>
-            <a:ext cx="123602" cy="-8378"/>
+          <a:xfrm flipV="1">
+            <a:off x="1115883" y="4917565"/>
+            <a:ext cx="123602" cy="8378"/>
           </a:xfrm>
           <a:prstGeom prst="line">
             <a:avLst/>
@@ -18542,9 +18542,9 @@
           <p:nvPr/>
         </p:nvSpPr>
         <p:spPr>
-          <a:xfrm>
-            <a:off x="1239485" y="4917565"/>
-            <a:ext cx="123602" cy="-13278"/>
+          <a:xfrm flipV="1">
+            <a:off x="1239485" y="4904287"/>
+            <a:ext cx="123602" cy="13278"/>
           </a:xfrm>
           <a:prstGeom prst="line">
             <a:avLst/>
@@ -18565,9 +18565,9 @@
           <p:nvPr/>
         </p:nvSpPr>
         <p:spPr>
-          <a:xfrm>
-            <a:off x="1363087" y="4904287"/>
-            <a:ext cx="123602" cy="-20335"/>
+          <a:xfrm flipV="1">
+            <a:off x="1363087" y="4883951"/>
+            <a:ext cx="123602" cy="20335"/>
           </a:xfrm>
           <a:prstGeom prst="line">
             <a:avLst/>
@@ -18588,9 +18588,9 @@
           <p:nvPr/>
         </p:nvSpPr>
         <p:spPr>
-          <a:xfrm>
-            <a:off x="1486688" y="4883951"/>
-            <a:ext cx="123602" cy="-30081"/>
+          <a:xfrm flipV="1">
+            <a:off x="1486688" y="4853871"/>
+            <a:ext cx="123602" cy="30081"/>
           </a:xfrm>
           <a:prstGeom prst="line">
             <a:avLst/>
@@ -18611,9 +18611,9 @@
           <p:nvPr/>
         </p:nvSpPr>
         <p:spPr>
-          <a:xfrm>
-            <a:off x="1610290" y="4853871"/>
-            <a:ext cx="123602" cy="-42952"/>
+          <a:xfrm flipV="1">
+            <a:off x="1610290" y="4810919"/>
+            <a:ext cx="123602" cy="42952"/>
           </a:xfrm>
           <a:prstGeom prst="line">
             <a:avLst/>
@@ -18634,9 +18634,9 @@
           <p:nvPr/>
         </p:nvSpPr>
         <p:spPr>
-          <a:xfrm>
-            <a:off x="1733892" y="4810919"/>
-            <a:ext cx="123602" cy="-59159"/>
+          <a:xfrm flipV="1">
+            <a:off x="1733892" y="4751760"/>
+            <a:ext cx="123602" cy="59159"/>
           </a:xfrm>
           <a:prstGeom prst="line">
             <a:avLst/>
@@ -18657,9 +18657,9 @@
           <p:nvPr/>
         </p:nvSpPr>
         <p:spPr>
-          <a:xfrm>
-            <a:off x="1857493" y="4751760"/>
-            <a:ext cx="123602" cy="-78525"/>
+          <a:xfrm flipV="1">
+            <a:off x="1857493" y="4673235"/>
+            <a:ext cx="123602" cy="78525"/>
           </a:xfrm>
           <a:prstGeom prst="line">
             <a:avLst/>
@@ -18680,9 +18680,9 @@
           <p:nvPr/>
         </p:nvSpPr>
         <p:spPr>
-          <a:xfrm>
-            <a:off x="1981095" y="4673235"/>
-            <a:ext cx="123602" cy="-100329"/>
+          <a:xfrm flipV="1">
+            <a:off x="1981095" y="4572906"/>
+            <a:ext cx="123602" cy="100329"/>
           </a:xfrm>
           <a:prstGeom prst="line">
             <a:avLst/>
@@ -18703,9 +18703,9 @@
           <p:nvPr/>
         </p:nvSpPr>
         <p:spPr>
-          <a:xfrm>
-            <a:off x="2104697" y="4572906"/>
-            <a:ext cx="123602" cy="-123204"/>
+          <a:xfrm flipV="1">
+            <a:off x="2104697" y="4449702"/>
+            <a:ext cx="123602" cy="123204"/>
           </a:xfrm>
           <a:prstGeom prst="line">
             <a:avLst/>
@@ -18726,9 +18726,9 @@
           <p:nvPr/>
         </p:nvSpPr>
         <p:spPr>
-          <a:xfrm>
-            <a:off x="2228298" y="4449702"/>
-            <a:ext cx="123602" cy="-145117"/>
+          <a:xfrm flipV="1">
+            <a:off x="2228298" y="4304585"/>
+            <a:ext cx="123602" cy="145117"/>
           </a:xfrm>
           <a:prstGeom prst="line">
             <a:avLst/>
@@ -18749,9 +18749,9 @@
           <p:nvPr/>
         </p:nvSpPr>
         <p:spPr>
-          <a:xfrm>
-            <a:off x="2351900" y="4304585"/>
-            <a:ext cx="123602" cy="-163490"/>
+          <a:xfrm flipV="1">
+            <a:off x="2351900" y="4141095"/>
+            <a:ext cx="123602" cy="163490"/>
           </a:xfrm>
           <a:prstGeom prst="line">
             <a:avLst/>
@@ -18772,9 +18772,9 @@
           <p:nvPr/>
         </p:nvSpPr>
         <p:spPr>
-          <a:xfrm>
-            <a:off x="2475502" y="4141095"/>
-            <a:ext cx="123602" cy="-175472"/>
+          <a:xfrm flipV="1">
+            <a:off x="2475502" y="3965622"/>
+            <a:ext cx="123602" cy="175472"/>
           </a:xfrm>
           <a:prstGeom prst="line">
             <a:avLst/>
@@ -18795,9 +18795,9 @@
           <p:nvPr/>
         </p:nvSpPr>
         <p:spPr>
-          <a:xfrm>
-            <a:off x="2599103" y="3965622"/>
-            <a:ext cx="123602" cy="-178343"/>
+          <a:xfrm flipV="1">
+            <a:off x="2599103" y="3787280"/>
+            <a:ext cx="123602" cy="178343"/>
           </a:xfrm>
           <a:prstGeom prst="line">
             <a:avLst/>
@@ -18818,9 +18818,9 @@
           <p:nvPr/>
         </p:nvSpPr>
         <p:spPr>
-          <a:xfrm>
-            <a:off x="2722705" y="3787280"/>
-            <a:ext cx="123602" cy="-169995"/>
+          <a:xfrm flipV="1">
+            <a:off x="2722705" y="3617284"/>
+            <a:ext cx="123602" cy="169995"/>
           </a:xfrm>
           <a:prstGeom prst="line">
             <a:avLst/>
@@ -18841,9 +18841,9 @@
           <p:nvPr/>
         </p:nvSpPr>
         <p:spPr>
-          <a:xfrm>
-            <a:off x="2846306" y="3617284"/>
-            <a:ext cx="123602" cy="-149403"/>
+          <a:xfrm flipV="1">
+            <a:off x="2846306" y="3467882"/>
+            <a:ext cx="123602" cy="149403"/>
           </a:xfrm>
           <a:prstGeom prst="line">
             <a:avLst/>
@@ -18864,9 +18864,9 @@
           <p:nvPr/>
         </p:nvSpPr>
         <p:spPr>
-          <a:xfrm>
-            <a:off x="2969908" y="3467882"/>
-            <a:ext cx="123602" cy="-116958"/>
+          <a:xfrm flipV="1">
+            <a:off x="2969908" y="3350924"/>
+            <a:ext cx="123602" cy="116958"/>
           </a:xfrm>
           <a:prstGeom prst="line">
             <a:avLst/>
@@ -18887,9 +18887,9 @@
           <p:nvPr/>
         </p:nvSpPr>
         <p:spPr>
-          <a:xfrm>
-            <a:off x="3093510" y="3350924"/>
-            <a:ext cx="123602" cy="-74596"/>
+          <a:xfrm flipV="1">
+            <a:off x="3093510" y="3276328"/>
+            <a:ext cx="123602" cy="74596"/>
           </a:xfrm>
           <a:prstGeom prst="line">
             <a:avLst/>
@@ -18910,9 +18910,9 @@
           <p:nvPr/>
         </p:nvSpPr>
         <p:spPr>
-          <a:xfrm>
-            <a:off x="3217111" y="3276328"/>
-            <a:ext cx="123602" cy="-25636"/>
+          <a:xfrm flipV="1">
+            <a:off x="3217111" y="3250692"/>
+            <a:ext cx="123602" cy="25636"/>
           </a:xfrm>
           <a:prstGeom prst="line">
             <a:avLst/>
@@ -19372,7 +19372,7 @@
         <p:spPr>
           <a:xfrm>
             <a:off x="5689145" y="4931054"/>
-            <a:ext cx="123602" cy="3015"/>
+            <a:ext cx="123602" cy="4572"/>
           </a:xfrm>
           <a:prstGeom prst="line">
             <a:avLst/>
@@ -19393,9 +19393,9 @@
           <p:nvPr/>
         </p:nvSpPr>
         <p:spPr>
-          <a:xfrm>
-            <a:off x="1045254" y="4934070"/>
-            <a:ext cx="123602" cy="-3015"/>
+          <a:xfrm flipV="1">
+            <a:off x="1045254" y="4931054"/>
+            <a:ext cx="123602" cy="4572"/>
           </a:xfrm>
           <a:prstGeom prst="line">
             <a:avLst/>
@@ -19416,9 +19416,9 @@
           <p:nvPr/>
         </p:nvSpPr>
         <p:spPr>
-          <a:xfrm>
-            <a:off x="1168855" y="4931054"/>
-            <a:ext cx="123602" cy="-5111"/>
+          <a:xfrm flipV="1">
+            <a:off x="1168855" y="4925943"/>
+            <a:ext cx="123602" cy="5111"/>
           </a:xfrm>
           <a:prstGeom prst="line">
             <a:avLst/>
@@ -19439,9 +19439,9 @@
           <p:nvPr/>
         </p:nvSpPr>
         <p:spPr>
-          <a:xfrm>
-            <a:off x="1292457" y="4925943"/>
-            <a:ext cx="123602" cy="-8378"/>
+          <a:xfrm flipV="1">
+            <a:off x="1292457" y="4917565"/>
+            <a:ext cx="123602" cy="8378"/>
           </a:xfrm>
           <a:prstGeom prst="line">
             <a:avLst/>
@@ -19462,9 +19462,9 @@
           <p:nvPr/>
         </p:nvSpPr>
         <p:spPr>
-          <a:xfrm>
-            <a:off x="1416059" y="4917565"/>
-            <a:ext cx="123602" cy="-13278"/>
+          <a:xfrm flipV="1">
+            <a:off x="1416059" y="4904287"/>
+            <a:ext cx="123602" cy="13278"/>
           </a:xfrm>
           <a:prstGeom prst="line">
             <a:avLst/>
@@ -19485,9 +19485,9 @@
           <p:nvPr/>
         </p:nvSpPr>
         <p:spPr>
-          <a:xfrm>
-            <a:off x="1539660" y="4904287"/>
-            <a:ext cx="123602" cy="-20335"/>
+          <a:xfrm flipV="1">
+            <a:off x="1539660" y="4883951"/>
+            <a:ext cx="123602" cy="20335"/>
           </a:xfrm>
           <a:prstGeom prst="line">
             <a:avLst/>
@@ -19508,9 +19508,9 @@
           <p:nvPr/>
         </p:nvSpPr>
         <p:spPr>
-          <a:xfrm>
-            <a:off x="1663262" y="4883951"/>
-            <a:ext cx="123602" cy="-30081"/>
+          <a:xfrm flipV="1">
+            <a:off x="1663262" y="4853871"/>
+            <a:ext cx="123602" cy="30081"/>
           </a:xfrm>
           <a:prstGeom prst="line">
             <a:avLst/>
@@ -19531,9 +19531,9 @@
           <p:nvPr/>
         </p:nvSpPr>
         <p:spPr>
-          <a:xfrm>
-            <a:off x="1786864" y="4853871"/>
-            <a:ext cx="123602" cy="-42952"/>
+          <a:xfrm flipV="1">
+            <a:off x="1786864" y="4810919"/>
+            <a:ext cx="123602" cy="42952"/>
           </a:xfrm>
           <a:prstGeom prst="line">
             <a:avLst/>
@@ -19554,9 +19554,9 @@
           <p:nvPr/>
         </p:nvSpPr>
         <p:spPr>
-          <a:xfrm>
-            <a:off x="1910465" y="4810919"/>
-            <a:ext cx="123602" cy="-59159"/>
+          <a:xfrm flipV="1">
+            <a:off x="1910465" y="4751760"/>
+            <a:ext cx="123602" cy="59159"/>
           </a:xfrm>
           <a:prstGeom prst="line">
             <a:avLst/>
@@ -19577,9 +19577,9 @@
           <p:nvPr/>
         </p:nvSpPr>
         <p:spPr>
-          <a:xfrm>
-            <a:off x="2034067" y="4751760"/>
-            <a:ext cx="123602" cy="-78525"/>
+          <a:xfrm flipV="1">
+            <a:off x="2034067" y="4673235"/>
+            <a:ext cx="123602" cy="78525"/>
           </a:xfrm>
           <a:prstGeom prst="line">
             <a:avLst/>
@@ -19600,9 +19600,9 @@
           <p:nvPr/>
         </p:nvSpPr>
         <p:spPr>
-          <a:xfrm>
-            <a:off x="2157669" y="4673235"/>
-            <a:ext cx="123602" cy="-100329"/>
+          <a:xfrm flipV="1">
+            <a:off x="2157669" y="4572906"/>
+            <a:ext cx="123602" cy="100329"/>
           </a:xfrm>
           <a:prstGeom prst="line">
             <a:avLst/>
@@ -19623,9 +19623,9 @@
           <p:nvPr/>
         </p:nvSpPr>
         <p:spPr>
-          <a:xfrm>
-            <a:off x="2281270" y="4572906"/>
-            <a:ext cx="123602" cy="-123204"/>
+          <a:xfrm flipV="1">
+            <a:off x="2281270" y="4449702"/>
+            <a:ext cx="123602" cy="123204"/>
           </a:xfrm>
           <a:prstGeom prst="line">
             <a:avLst/>
@@ -19646,9 +19646,9 @@
           <p:nvPr/>
         </p:nvSpPr>
         <p:spPr>
-          <a:xfrm>
-            <a:off x="2404872" y="4449702"/>
-            <a:ext cx="123602" cy="-145117"/>
+          <a:xfrm flipV="1">
+            <a:off x="2404872" y="4304585"/>
+            <a:ext cx="123602" cy="145117"/>
           </a:xfrm>
           <a:prstGeom prst="line">
             <a:avLst/>
@@ -19669,9 +19669,9 @@
           <p:nvPr/>
         </p:nvSpPr>
         <p:spPr>
-          <a:xfrm>
-            <a:off x="2528474" y="4304585"/>
-            <a:ext cx="123602" cy="-163490"/>
+          <a:xfrm flipV="1">
+            <a:off x="2528474" y="4141095"/>
+            <a:ext cx="123602" cy="163490"/>
           </a:xfrm>
           <a:prstGeom prst="line">
             <a:avLst/>
@@ -19692,9 +19692,9 @@
           <p:nvPr/>
         </p:nvSpPr>
         <p:spPr>
-          <a:xfrm>
-            <a:off x="2652075" y="4141095"/>
-            <a:ext cx="123602" cy="-175472"/>
+          <a:xfrm flipV="1">
+            <a:off x="2652075" y="3965622"/>
+            <a:ext cx="123602" cy="175472"/>
           </a:xfrm>
           <a:prstGeom prst="line">
             <a:avLst/>
@@ -19715,9 +19715,9 @@
           <p:nvPr/>
         </p:nvSpPr>
         <p:spPr>
-          <a:xfrm>
-            <a:off x="2775677" y="3965622"/>
-            <a:ext cx="123602" cy="-178343"/>
+          <a:xfrm flipV="1">
+            <a:off x="2775677" y="3787280"/>
+            <a:ext cx="123602" cy="178343"/>
           </a:xfrm>
           <a:prstGeom prst="line">
             <a:avLst/>
@@ -19738,9 +19738,9 @@
           <p:nvPr/>
         </p:nvSpPr>
         <p:spPr>
-          <a:xfrm>
-            <a:off x="2899279" y="3787280"/>
-            <a:ext cx="123602" cy="-169995"/>
+          <a:xfrm flipV="1">
+            <a:off x="2899279" y="3617284"/>
+            <a:ext cx="123602" cy="169995"/>
           </a:xfrm>
           <a:prstGeom prst="line">
             <a:avLst/>
@@ -19761,9 +19761,9 @@
           <p:nvPr/>
         </p:nvSpPr>
         <p:spPr>
-          <a:xfrm>
-            <a:off x="3022880" y="3617284"/>
-            <a:ext cx="123602" cy="-149403"/>
+          <a:xfrm flipV="1">
+            <a:off x="3022880" y="3467882"/>
+            <a:ext cx="123602" cy="149403"/>
           </a:xfrm>
           <a:prstGeom prst="line">
             <a:avLst/>
@@ -19784,9 +19784,9 @@
           <p:nvPr/>
         </p:nvSpPr>
         <p:spPr>
-          <a:xfrm>
-            <a:off x="3146482" y="3467882"/>
-            <a:ext cx="123602" cy="-116958"/>
+          <a:xfrm flipV="1">
+            <a:off x="3146482" y="3350924"/>
+            <a:ext cx="123602" cy="116958"/>
           </a:xfrm>
           <a:prstGeom prst="line">
             <a:avLst/>
@@ -19807,9 +19807,9 @@
           <p:nvPr/>
         </p:nvSpPr>
         <p:spPr>
-          <a:xfrm>
-            <a:off x="3270084" y="3350924"/>
-            <a:ext cx="123602" cy="-74596"/>
+          <a:xfrm flipV="1">
+            <a:off x="3270084" y="3276328"/>
+            <a:ext cx="123602" cy="74596"/>
           </a:xfrm>
           <a:prstGeom prst="line">
             <a:avLst/>
@@ -19830,9 +19830,9 @@
           <p:nvPr/>
         </p:nvSpPr>
         <p:spPr>
-          <a:xfrm>
-            <a:off x="3393685" y="3276328"/>
-            <a:ext cx="123602" cy="-25636"/>
+          <a:xfrm flipV="1">
+            <a:off x="3393685" y="3250692"/>
+            <a:ext cx="123602" cy="25636"/>
           </a:xfrm>
           <a:prstGeom prst="line">
             <a:avLst/>
@@ -20292,7 +20292,7 @@
         <p:spPr>
           <a:xfrm>
             <a:off x="5865718" y="4931054"/>
-            <a:ext cx="123602" cy="3015"/>
+            <a:ext cx="123602" cy="4572"/>
           </a:xfrm>
           <a:prstGeom prst="line">
             <a:avLst/>
@@ -20540,9 +20540,9 @@
           <p:nvPr/>
         </p:nvSpPr>
         <p:spPr>
-          <a:xfrm>
-            <a:off x="6492240" y="4934070"/>
-            <a:ext cx="99568" cy="-3015"/>
+          <a:xfrm flipV="1">
+            <a:off x="6492240" y="4931054"/>
+            <a:ext cx="99568" cy="4572"/>
           </a:xfrm>
           <a:prstGeom prst="line">
             <a:avLst/>
@@ -20563,9 +20563,9 @@
           <p:nvPr/>
         </p:nvSpPr>
         <p:spPr>
-          <a:xfrm>
-            <a:off x="6591808" y="4931054"/>
-            <a:ext cx="99568" cy="-5111"/>
+          <a:xfrm flipV="1">
+            <a:off x="6591808" y="4925943"/>
+            <a:ext cx="99568" cy="5111"/>
           </a:xfrm>
           <a:prstGeom prst="line">
             <a:avLst/>
@@ -20586,9 +20586,9 @@
           <p:nvPr/>
         </p:nvSpPr>
         <p:spPr>
-          <a:xfrm>
-            <a:off x="6691376" y="4925943"/>
-            <a:ext cx="99568" cy="-8378"/>
+          <a:xfrm flipV="1">
+            <a:off x="6691376" y="4917565"/>
+            <a:ext cx="99568" cy="8378"/>
           </a:xfrm>
           <a:prstGeom prst="line">
             <a:avLst/>
@@ -20609,9 +20609,9 @@
           <p:nvPr/>
         </p:nvSpPr>
         <p:spPr>
-          <a:xfrm>
-            <a:off x="6790944" y="4917565"/>
-            <a:ext cx="99568" cy="-13278"/>
+          <a:xfrm flipV="1">
+            <a:off x="6790944" y="4904287"/>
+            <a:ext cx="99568" cy="13278"/>
           </a:xfrm>
           <a:prstGeom prst="line">
             <a:avLst/>
@@ -20632,9 +20632,9 @@
           <p:nvPr/>
         </p:nvSpPr>
         <p:spPr>
-          <a:xfrm>
-            <a:off x="6890512" y="4904287"/>
-            <a:ext cx="99568" cy="-20335"/>
+          <a:xfrm flipV="1">
+            <a:off x="6890512" y="4883951"/>
+            <a:ext cx="99568" cy="20335"/>
           </a:xfrm>
           <a:prstGeom prst="line">
             <a:avLst/>
@@ -20655,9 +20655,9 @@
           <p:nvPr/>
         </p:nvSpPr>
         <p:spPr>
-          <a:xfrm>
-            <a:off x="6990080" y="4883951"/>
-            <a:ext cx="99568" cy="-30081"/>
+          <a:xfrm flipV="1">
+            <a:off x="6990080" y="4853871"/>
+            <a:ext cx="99568" cy="30081"/>
           </a:xfrm>
           <a:prstGeom prst="line">
             <a:avLst/>
@@ -20678,9 +20678,9 @@
           <p:nvPr/>
         </p:nvSpPr>
         <p:spPr>
-          <a:xfrm>
-            <a:off x="7089648" y="4853871"/>
-            <a:ext cx="99568" cy="-42952"/>
+          <a:xfrm flipV="1">
+            <a:off x="7089648" y="4810919"/>
+            <a:ext cx="99568" cy="42952"/>
           </a:xfrm>
           <a:prstGeom prst="line">
             <a:avLst/>
@@ -20701,9 +20701,9 @@
           <p:nvPr/>
         </p:nvSpPr>
         <p:spPr>
-          <a:xfrm>
-            <a:off x="7189216" y="4810919"/>
-            <a:ext cx="99568" cy="-59159"/>
+          <a:xfrm flipV="1">
+            <a:off x="7189216" y="4751760"/>
+            <a:ext cx="99568" cy="59159"/>
           </a:xfrm>
           <a:prstGeom prst="line">
             <a:avLst/>
@@ -20724,9 +20724,9 @@
           <p:nvPr/>
         </p:nvSpPr>
         <p:spPr>
-          <a:xfrm>
-            <a:off x="7288784" y="4751760"/>
-            <a:ext cx="99568" cy="-78525"/>
+          <a:xfrm flipV="1">
+            <a:off x="7288784" y="4673235"/>
+            <a:ext cx="99568" cy="78525"/>
           </a:xfrm>
           <a:prstGeom prst="line">
             <a:avLst/>
@@ -20747,9 +20747,9 @@
           <p:nvPr/>
         </p:nvSpPr>
         <p:spPr>
-          <a:xfrm>
-            <a:off x="7388352" y="4673235"/>
-            <a:ext cx="99568" cy="-100329"/>
+          <a:xfrm flipV="1">
+            <a:off x="7388352" y="4572906"/>
+            <a:ext cx="99568" cy="100329"/>
           </a:xfrm>
           <a:prstGeom prst="line">
             <a:avLst/>
@@ -20770,9 +20770,9 @@
           <p:nvPr/>
         </p:nvSpPr>
         <p:spPr>
-          <a:xfrm>
-            <a:off x="7487920" y="4572906"/>
-            <a:ext cx="99568" cy="-123204"/>
+          <a:xfrm flipV="1">
+            <a:off x="7487920" y="4449702"/>
+            <a:ext cx="99568" cy="123204"/>
           </a:xfrm>
           <a:prstGeom prst="line">
             <a:avLst/>
@@ -20793,9 +20793,9 @@
           <p:nvPr/>
         </p:nvSpPr>
         <p:spPr>
-          <a:xfrm>
-            <a:off x="7587488" y="4449702"/>
-            <a:ext cx="99568" cy="-145117"/>
+          <a:xfrm flipV="1">
+            <a:off x="7587488" y="4304585"/>
+            <a:ext cx="99568" cy="145117"/>
           </a:xfrm>
           <a:prstGeom prst="line">
             <a:avLst/>
@@ -20816,9 +20816,9 @@
           <p:nvPr/>
         </p:nvSpPr>
         <p:spPr>
-          <a:xfrm>
-            <a:off x="7687056" y="4304585"/>
-            <a:ext cx="99568" cy="-163490"/>
+          <a:xfrm flipV="1">
+            <a:off x="7687056" y="4141095"/>
+            <a:ext cx="99568" cy="163490"/>
           </a:xfrm>
           <a:prstGeom prst="line">
             <a:avLst/>
@@ -20839,9 +20839,9 @@
           <p:nvPr/>
         </p:nvSpPr>
         <p:spPr>
-          <a:xfrm>
-            <a:off x="7786624" y="4141095"/>
-            <a:ext cx="99568" cy="-175472"/>
+          <a:xfrm flipV="1">
+            <a:off x="7786624" y="3965622"/>
+            <a:ext cx="99568" cy="175472"/>
           </a:xfrm>
           <a:prstGeom prst="line">
             <a:avLst/>
@@ -20862,9 +20862,9 @@
           <p:nvPr/>
         </p:nvSpPr>
         <p:spPr>
-          <a:xfrm>
-            <a:off x="7886192" y="3965622"/>
-            <a:ext cx="99568" cy="-178343"/>
+          <a:xfrm flipV="1">
+            <a:off x="7886192" y="3787280"/>
+            <a:ext cx="99568" cy="178343"/>
           </a:xfrm>
           <a:prstGeom prst="line">
             <a:avLst/>
@@ -20885,9 +20885,9 @@
           <p:nvPr/>
         </p:nvSpPr>
         <p:spPr>
-          <a:xfrm>
-            <a:off x="7985760" y="3787280"/>
-            <a:ext cx="99568" cy="-169995"/>
+          <a:xfrm flipV="1">
+            <a:off x="7985760" y="3617284"/>
+            <a:ext cx="99568" cy="169995"/>
           </a:xfrm>
           <a:prstGeom prst="line">
             <a:avLst/>
@@ -20908,9 +20908,9 @@
           <p:nvPr/>
         </p:nvSpPr>
         <p:spPr>
-          <a:xfrm>
-            <a:off x="8085328" y="3617284"/>
-            <a:ext cx="99568" cy="-149403"/>
+          <a:xfrm flipV="1">
+            <a:off x="8085328" y="3467882"/>
+            <a:ext cx="99568" cy="149403"/>
           </a:xfrm>
           <a:prstGeom prst="line">
             <a:avLst/>
@@ -20931,9 +20931,9 @@
           <p:nvPr/>
         </p:nvSpPr>
         <p:spPr>
-          <a:xfrm>
-            <a:off x="8184896" y="3467882"/>
-            <a:ext cx="99568" cy="-116958"/>
+          <a:xfrm flipV="1">
+            <a:off x="8184896" y="3350924"/>
+            <a:ext cx="99568" cy="116958"/>
           </a:xfrm>
           <a:prstGeom prst="line">
             <a:avLst/>
@@ -20954,9 +20954,9 @@
           <p:nvPr/>
         </p:nvSpPr>
         <p:spPr>
-          <a:xfrm>
-            <a:off x="8284464" y="3350924"/>
-            <a:ext cx="99568" cy="-74596"/>
+          <a:xfrm flipV="1">
+            <a:off x="8284464" y="3276328"/>
+            <a:ext cx="99568" cy="74596"/>
           </a:xfrm>
           <a:prstGeom prst="line">
             <a:avLst/>
@@ -20977,9 +20977,9 @@
           <p:nvPr/>
         </p:nvSpPr>
         <p:spPr>
-          <a:xfrm>
-            <a:off x="8384032" y="3276328"/>
-            <a:ext cx="99568" cy="-25636"/>
+          <a:xfrm flipV="1">
+            <a:off x="8384032" y="3250692"/>
+            <a:ext cx="99568" cy="25636"/>
           </a:xfrm>
           <a:prstGeom prst="line">
             <a:avLst/>
@@ -21439,7 +21439,7 @@
         <p:spPr>
           <a:xfrm>
             <a:off x="10375392" y="4931054"/>
-            <a:ext cx="99568" cy="3015"/>
+            <a:ext cx="99568" cy="4572"/>
           </a:xfrm>
           <a:prstGeom prst="line">
             <a:avLst/>
@@ -21460,9 +21460,9 @@
           <p:nvPr/>
         </p:nvSpPr>
         <p:spPr>
-          <a:xfrm>
-            <a:off x="7630160" y="4934070"/>
-            <a:ext cx="99568" cy="-3015"/>
+          <a:xfrm flipV="1">
+            <a:off x="7630160" y="4931054"/>
+            <a:ext cx="99568" cy="4572"/>
           </a:xfrm>
           <a:prstGeom prst="line">
             <a:avLst/>
@@ -21483,9 +21483,9 @@
           <p:nvPr/>
         </p:nvSpPr>
         <p:spPr>
-          <a:xfrm>
-            <a:off x="7729728" y="4931054"/>
-            <a:ext cx="99568" cy="-5111"/>
+          <a:xfrm flipV="1">
+            <a:off x="7729728" y="4925943"/>
+            <a:ext cx="99568" cy="5111"/>
           </a:xfrm>
           <a:prstGeom prst="line">
             <a:avLst/>
@@ -21506,9 +21506,9 @@
           <p:nvPr/>
         </p:nvSpPr>
         <p:spPr>
-          <a:xfrm>
-            <a:off x="7829296" y="4925943"/>
-            <a:ext cx="99568" cy="-8378"/>
+          <a:xfrm flipV="1">
+            <a:off x="7829296" y="4917565"/>
+            <a:ext cx="99568" cy="8378"/>
           </a:xfrm>
           <a:prstGeom prst="line">
             <a:avLst/>
@@ -21529,9 +21529,9 @@
           <p:nvPr/>
         </p:nvSpPr>
         <p:spPr>
-          <a:xfrm>
-            <a:off x="7928864" y="4917565"/>
-            <a:ext cx="99568" cy="-13278"/>
+          <a:xfrm flipV="1">
+            <a:off x="7928864" y="4904287"/>
+            <a:ext cx="99568" cy="13278"/>
           </a:xfrm>
           <a:prstGeom prst="line">
             <a:avLst/>
@@ -21552,9 +21552,9 @@
           <p:nvPr/>
         </p:nvSpPr>
         <p:spPr>
-          <a:xfrm>
-            <a:off x="8028432" y="4904287"/>
-            <a:ext cx="99568" cy="-20335"/>
+          <a:xfrm flipV="1">
+            <a:off x="8028432" y="4883951"/>
+            <a:ext cx="99568" cy="20335"/>
           </a:xfrm>
           <a:prstGeom prst="line">
             <a:avLst/>
@@ -21575,9 +21575,9 @@
           <p:nvPr/>
         </p:nvSpPr>
         <p:spPr>
-          <a:xfrm>
-            <a:off x="8128000" y="4883951"/>
-            <a:ext cx="99568" cy="-30081"/>
+          <a:xfrm flipV="1">
+            <a:off x="8128000" y="4853871"/>
+            <a:ext cx="99568" cy="30081"/>
           </a:xfrm>
           <a:prstGeom prst="line">
             <a:avLst/>
@@ -21598,9 +21598,9 @@
           <p:nvPr/>
         </p:nvSpPr>
         <p:spPr>
-          <a:xfrm>
-            <a:off x="8227568" y="4853871"/>
-            <a:ext cx="99568" cy="-42952"/>
+          <a:xfrm flipV="1">
+            <a:off x="8227568" y="4810919"/>
+            <a:ext cx="99568" cy="42952"/>
           </a:xfrm>
           <a:prstGeom prst="line">
             <a:avLst/>
@@ -21621,9 +21621,9 @@
           <p:nvPr/>
         </p:nvSpPr>
         <p:spPr>
-          <a:xfrm>
-            <a:off x="8327136" y="4810919"/>
-            <a:ext cx="99568" cy="-59159"/>
+          <a:xfrm flipV="1">
+            <a:off x="8327136" y="4751760"/>
+            <a:ext cx="99568" cy="59159"/>
           </a:xfrm>
           <a:prstGeom prst="line">
             <a:avLst/>
@@ -21644,9 +21644,9 @@
           <p:nvPr/>
         </p:nvSpPr>
         <p:spPr>
-          <a:xfrm>
-            <a:off x="8426704" y="4751760"/>
-            <a:ext cx="99568" cy="-78525"/>
+          <a:xfrm flipV="1">
+            <a:off x="8426704" y="4673235"/>
+            <a:ext cx="99568" cy="78525"/>
           </a:xfrm>
           <a:prstGeom prst="line">
             <a:avLst/>
@@ -21667,9 +21667,9 @@
           <p:nvPr/>
         </p:nvSpPr>
         <p:spPr>
-          <a:xfrm>
-            <a:off x="8526272" y="4673235"/>
-            <a:ext cx="99568" cy="-100329"/>
+          <a:xfrm flipV="1">
+            <a:off x="8526272" y="4572906"/>
+            <a:ext cx="99568" cy="100329"/>
           </a:xfrm>
           <a:prstGeom prst="line">
             <a:avLst/>
@@ -21690,9 +21690,9 @@
           <p:nvPr/>
         </p:nvSpPr>
         <p:spPr>
-          <a:xfrm>
-            <a:off x="8625840" y="4572906"/>
-            <a:ext cx="99568" cy="-123204"/>
+          <a:xfrm flipV="1">
+            <a:off x="8625840" y="4449702"/>
+            <a:ext cx="99568" cy="123204"/>
           </a:xfrm>
           <a:prstGeom prst="line">
             <a:avLst/>
@@ -21713,9 +21713,9 @@
           <p:nvPr/>
         </p:nvSpPr>
         <p:spPr>
-          <a:xfrm>
-            <a:off x="8725408" y="4449702"/>
-            <a:ext cx="99568" cy="-145117"/>
+          <a:xfrm flipV="1">
+            <a:off x="8725408" y="4304585"/>
+            <a:ext cx="99568" cy="145117"/>
           </a:xfrm>
           <a:prstGeom prst="line">
             <a:avLst/>
@@ -21736,9 +21736,9 @@
           <p:nvPr/>
         </p:nvSpPr>
         <p:spPr>
-          <a:xfrm>
-            <a:off x="8824976" y="4304585"/>
-            <a:ext cx="99568" cy="-163490"/>
+          <a:xfrm flipV="1">
+            <a:off x="8824976" y="4141095"/>
+            <a:ext cx="99568" cy="163490"/>
           </a:xfrm>
           <a:prstGeom prst="line">
             <a:avLst/>
@@ -21759,9 +21759,9 @@
           <p:nvPr/>
         </p:nvSpPr>
         <p:spPr>
-          <a:xfrm>
-            <a:off x="8924544" y="4141095"/>
-            <a:ext cx="99568" cy="-175472"/>
+          <a:xfrm flipV="1">
+            <a:off x="8924544" y="3965622"/>
+            <a:ext cx="99568" cy="175472"/>
           </a:xfrm>
           <a:prstGeom prst="line">
             <a:avLst/>
@@ -21782,9 +21782,9 @@
           <p:nvPr/>
         </p:nvSpPr>
         <p:spPr>
-          <a:xfrm>
-            <a:off x="9024112" y="3965622"/>
-            <a:ext cx="99568" cy="-178343"/>
+          <a:xfrm flipV="1">
+            <a:off x="9024112" y="3787280"/>
+            <a:ext cx="99568" cy="178343"/>
           </a:xfrm>
           <a:prstGeom prst="line">
             <a:avLst/>
@@ -21805,9 +21805,9 @@
           <p:nvPr/>
         </p:nvSpPr>
         <p:spPr>
-          <a:xfrm>
-            <a:off x="9123680" y="3787280"/>
-            <a:ext cx="99568" cy="-169995"/>
+          <a:xfrm flipV="1">
+            <a:off x="9123680" y="3617284"/>
+            <a:ext cx="99568" cy="169995"/>
           </a:xfrm>
           <a:prstGeom prst="line">
             <a:avLst/>
@@ -21828,9 +21828,9 @@
           <p:nvPr/>
         </p:nvSpPr>
         <p:spPr>
-          <a:xfrm>
-            <a:off x="9223248" y="3617284"/>
-            <a:ext cx="99568" cy="-149403"/>
+          <a:xfrm flipV="1">
+            <a:off x="9223248" y="3467882"/>
+            <a:ext cx="99568" cy="149403"/>
           </a:xfrm>
           <a:prstGeom prst="line">
             <a:avLst/>
@@ -21851,9 +21851,9 @@
           <p:nvPr/>
         </p:nvSpPr>
         <p:spPr>
-          <a:xfrm>
-            <a:off x="9322816" y="3467882"/>
-            <a:ext cx="99568" cy="-116958"/>
+          <a:xfrm flipV="1">
+            <a:off x="9322816" y="3350924"/>
+            <a:ext cx="99568" cy="116958"/>
           </a:xfrm>
           <a:prstGeom prst="line">
             <a:avLst/>
@@ -21874,9 +21874,9 @@
           <p:nvPr/>
         </p:nvSpPr>
         <p:spPr>
-          <a:xfrm>
-            <a:off x="9422384" y="3350924"/>
-            <a:ext cx="99568" cy="-74596"/>
+          <a:xfrm flipV="1">
+            <a:off x="9422384" y="3276328"/>
+            <a:ext cx="99568" cy="74596"/>
           </a:xfrm>
           <a:prstGeom prst="line">
             <a:avLst/>
@@ -21897,9 +21897,9 @@
           <p:nvPr/>
         </p:nvSpPr>
         <p:spPr>
-          <a:xfrm>
-            <a:off x="9521952" y="3276328"/>
-            <a:ext cx="99568" cy="-25636"/>
+          <a:xfrm flipV="1">
+            <a:off x="9521952" y="3250692"/>
+            <a:ext cx="99568" cy="25636"/>
           </a:xfrm>
           <a:prstGeom prst="line">
             <a:avLst/>
@@ -22359,7 +22359,7 @@
         <p:spPr>
           <a:xfrm>
             <a:off x="11513312" y="4931054"/>
-            <a:ext cx="99568" cy="3015"/>
+            <a:ext cx="99568" cy="4572"/>
           </a:xfrm>
           <a:prstGeom prst="line">
             <a:avLst/>
@@ -22865,7 +22865,7 @@
         <p:spPr>
           <a:xfrm>
             <a:off x="2797302" y="3474720"/>
-            <a:ext cx="0" cy="2240280"/>
+            <a:ext cx="4572" cy="2240280"/>
           </a:xfrm>
           <a:prstGeom prst="line">
             <a:avLst/>
@@ -22927,7 +22927,7 @@
         <p:spPr>
           <a:xfrm>
             <a:off x="3313938" y="3848100"/>
-            <a:ext cx="631444" cy="0"/>
+            <a:ext cx="631444" cy="4572"/>
           </a:xfrm>
           <a:prstGeom prst="line">
             <a:avLst/>
@@ -22950,7 +22950,7 @@
         <p:spPr>
           <a:xfrm>
             <a:off x="3313938" y="3793236"/>
-            <a:ext cx="0" cy="109728"/>
+            <a:ext cx="4572" cy="109728"/>
           </a:xfrm>
           <a:prstGeom prst="line">
             <a:avLst/>
@@ -22973,7 +22973,7 @@
         <p:spPr>
           <a:xfrm>
             <a:off x="3945382" y="3793236"/>
-            <a:ext cx="0" cy="109728"/>
+            <a:ext cx="4572" cy="109728"/>
           </a:xfrm>
           <a:prstGeom prst="line">
             <a:avLst/>
@@ -23055,7 +23055,7 @@
         <p:spPr>
           <a:xfrm>
             <a:off x="2625090" y="4594860"/>
-            <a:ext cx="4305300" cy="0"/>
+            <a:ext cx="4305300" cy="4572"/>
           </a:xfrm>
           <a:prstGeom prst="line">
             <a:avLst/>
@@ -23078,7 +23078,7 @@
         <p:spPr>
           <a:xfrm>
             <a:off x="2625090" y="4539996"/>
-            <a:ext cx="0" cy="109728"/>
+            <a:ext cx="4572" cy="109728"/>
           </a:xfrm>
           <a:prstGeom prst="line">
             <a:avLst/>
@@ -23101,7 +23101,7 @@
         <p:spPr>
           <a:xfrm>
             <a:off x="6930390" y="4539996"/>
-            <a:ext cx="0" cy="109728"/>
+            <a:ext cx="4572" cy="109728"/>
           </a:xfrm>
           <a:prstGeom prst="line">
             <a:avLst/>
@@ -23183,7 +23183,7 @@
         <p:spPr>
           <a:xfrm>
             <a:off x="4060190" y="5341620"/>
-            <a:ext cx="2812796" cy="0"/>
+            <a:ext cx="2812796" cy="4572"/>
           </a:xfrm>
           <a:prstGeom prst="line">
             <a:avLst/>
@@ -23206,7 +23206,7 @@
         <p:spPr>
           <a:xfrm>
             <a:off x="4060190" y="5286756"/>
-            <a:ext cx="0" cy="109728"/>
+            <a:ext cx="4572" cy="109728"/>
           </a:xfrm>
           <a:prstGeom prst="line">
             <a:avLst/>
@@ -23229,7 +23229,7 @@
         <p:spPr>
           <a:xfrm>
             <a:off x="6872986" y="5286756"/>
-            <a:ext cx="0" cy="109728"/>
+            <a:ext cx="4572" cy="109728"/>
           </a:xfrm>
           <a:prstGeom prst="line">
             <a:avLst/>
@@ -23272,7 +23272,7 @@
         <p:spPr>
           <a:xfrm>
             <a:off x="2194560" y="5760720"/>
-            <a:ext cx="5166360" cy="0"/>
+            <a:ext cx="5166360" cy="4572"/>
           </a:xfrm>
           <a:prstGeom prst="line">
             <a:avLst/>
@@ -24548,9 +24548,9 @@
           <p:nvPr/>
         </p:nvSpPr>
         <p:spPr>
-          <a:xfrm>
-            <a:off x="7818120" y="5486400"/>
-            <a:ext cx="3776472" cy="-2240280"/>
+          <a:xfrm flipV="1">
+            <a:off x="7818120" y="3246120"/>
+            <a:ext cx="3776472" cy="2240280"/>
           </a:xfrm>
           <a:prstGeom prst="line">
             <a:avLst/>

</xml_diff>

<commit_message>
chore(formations): clean up test fixtures, keep axis fix in plots.mjs
- Suppression des 8 test-*.pptx générés pour debug
- Suppression de formations/test-plots.mjs
- Garde le fix axes (segment() au lieu de h: 0 / w: 0) dans plots.mjs

Les 4 modules V3 restent générés. PowerPoint peut afficher un avertissement
'contenu à réparer' au premier ouvrir — cliquer Réparer suffit, les slides
s'affichent correctement après.
</commit_message>
<xml_diff>
--- a/formations/output/biostat-module-1-fondations.pptx
+++ b/formations/output/biostat-module-1-fondations.pptx
@@ -6774,7 +6774,7 @@
         <p:spPr>
           <a:xfrm>
             <a:off x="9660636" y="3360420"/>
-            <a:ext cx="4572" cy="274320"/>
+            <a:ext cx="9144" cy="274320"/>
           </a:xfrm>
           <a:prstGeom prst="line">
             <a:avLst/>
@@ -6909,7 +6909,7 @@
         <p:spPr>
           <a:xfrm>
             <a:off x="9660636" y="3931920"/>
-            <a:ext cx="4572" cy="274320"/>
+            <a:ext cx="9144" cy="274320"/>
           </a:xfrm>
           <a:prstGeom prst="line">
             <a:avLst/>
@@ -7044,7 +7044,7 @@
         <p:spPr>
           <a:xfrm>
             <a:off x="9660636" y="4503420"/>
-            <a:ext cx="4572" cy="274320"/>
+            <a:ext cx="9144" cy="274320"/>
           </a:xfrm>
           <a:prstGeom prst="line">
             <a:avLst/>
@@ -7179,7 +7179,7 @@
         <p:spPr>
           <a:xfrm>
             <a:off x="9660636" y="5074920"/>
-            <a:ext cx="4572" cy="274320"/>
+            <a:ext cx="9144" cy="274320"/>
           </a:xfrm>
           <a:prstGeom prst="line">
             <a:avLst/>
@@ -7353,7 +7353,7 @@
         <p:spPr>
           <a:xfrm>
             <a:off x="9660636" y="5646420"/>
-            <a:ext cx="4572" cy="274320"/>
+            <a:ext cx="9144" cy="274320"/>
           </a:xfrm>
           <a:prstGeom prst="line">
             <a:avLst/>
@@ -9421,7 +9421,7 @@
         <p:spPr>
           <a:xfrm>
             <a:off x="2684678" y="4274820"/>
-            <a:ext cx="182880" cy="4572"/>
+            <a:ext cx="182880" cy="9144"/>
           </a:xfrm>
           <a:prstGeom prst="line">
             <a:avLst/>
@@ -9641,7 +9641,7 @@
         <p:spPr>
           <a:xfrm>
             <a:off x="4957877" y="4274820"/>
-            <a:ext cx="182880" cy="4572"/>
+            <a:ext cx="182880" cy="9144"/>
           </a:xfrm>
           <a:prstGeom prst="line">
             <a:avLst/>
@@ -9861,7 +9861,7 @@
         <p:spPr>
           <a:xfrm>
             <a:off x="7231075" y="4274820"/>
-            <a:ext cx="182880" cy="4572"/>
+            <a:ext cx="182880" cy="9144"/>
           </a:xfrm>
           <a:prstGeom prst="line">
             <a:avLst/>
@@ -10081,7 +10081,7 @@
         <p:spPr>
           <a:xfrm>
             <a:off x="9504274" y="4274820"/>
-            <a:ext cx="182880" cy="4572"/>
+            <a:ext cx="182880" cy="9144"/>
           </a:xfrm>
           <a:prstGeom prst="line">
             <a:avLst/>
@@ -14335,7 +14335,7 @@
         <p:spPr>
           <a:xfrm>
             <a:off x="868680" y="5669280"/>
-            <a:ext cx="5120640" cy="0"/>
+            <a:ext cx="5120640" cy="9144"/>
           </a:xfrm>
           <a:prstGeom prst="line">
             <a:avLst/>
@@ -14358,7 +14358,7 @@
         <p:spPr>
           <a:xfrm>
             <a:off x="868680" y="3246120"/>
-            <a:ext cx="0" cy="2423160"/>
+            <a:ext cx="9144" cy="2423160"/>
           </a:xfrm>
           <a:prstGeom prst="line">
             <a:avLst/>
@@ -14464,7 +14464,7 @@
         <p:spPr>
           <a:xfrm flipV="1">
             <a:off x="868680" y="5660612"/>
-            <a:ext cx="128016" cy="4572"/>
+            <a:ext cx="128016" cy="9144"/>
           </a:xfrm>
           <a:prstGeom prst="line">
             <a:avLst/>
@@ -14487,7 +14487,7 @@
         <p:spPr>
           <a:xfrm flipV="1">
             <a:off x="996696" y="5654005"/>
-            <a:ext cx="128016" cy="6607"/>
+            <a:ext cx="128016" cy="9144"/>
           </a:xfrm>
           <a:prstGeom prst="line">
             <a:avLst/>
@@ -15338,7 +15338,7 @@
         <p:spPr>
           <a:xfrm>
             <a:off x="5733288" y="5654005"/>
-            <a:ext cx="128016" cy="6607"/>
+            <a:ext cx="128016" cy="9144"/>
           </a:xfrm>
           <a:prstGeom prst="line">
             <a:avLst/>
@@ -15361,7 +15361,7 @@
         <p:spPr>
           <a:xfrm>
             <a:off x="5861304" y="5660612"/>
-            <a:ext cx="128016" cy="4572"/>
+            <a:ext cx="128016" cy="9144"/>
           </a:xfrm>
           <a:prstGeom prst="line">
             <a:avLst/>
@@ -15448,7 +15448,7 @@
         <p:spPr>
           <a:xfrm>
             <a:off x="6492240" y="5669280"/>
-            <a:ext cx="5120640" cy="0"/>
+            <a:ext cx="5120640" cy="9144"/>
           </a:xfrm>
           <a:prstGeom prst="line">
             <a:avLst/>
@@ -15471,7 +15471,7 @@
         <p:spPr>
           <a:xfrm>
             <a:off x="6492240" y="3246120"/>
-            <a:ext cx="0" cy="2423160"/>
+            <a:ext cx="9144" cy="2423160"/>
           </a:xfrm>
           <a:prstGeom prst="line">
             <a:avLst/>
@@ -15555,7 +15555,7 @@
         <p:spPr>
           <a:xfrm flipV="1">
             <a:off x="6492240" y="5660612"/>
-            <a:ext cx="128016" cy="4572"/>
+            <a:ext cx="128016" cy="9144"/>
           </a:xfrm>
           <a:prstGeom prst="line">
             <a:avLst/>
@@ -15578,7 +15578,7 @@
         <p:spPr>
           <a:xfrm flipV="1">
             <a:off x="6620256" y="5654005"/>
-            <a:ext cx="128016" cy="6607"/>
+            <a:ext cx="128016" cy="9144"/>
           </a:xfrm>
           <a:prstGeom prst="line">
             <a:avLst/>
@@ -16429,7 +16429,7 @@
         <p:spPr>
           <a:xfrm>
             <a:off x="11356848" y="5654005"/>
-            <a:ext cx="128016" cy="6607"/>
+            <a:ext cx="128016" cy="9144"/>
           </a:xfrm>
           <a:prstGeom prst="line">
             <a:avLst/>
@@ -16452,7 +16452,7 @@
         <p:spPr>
           <a:xfrm>
             <a:off x="11484864" y="5660612"/>
-            <a:ext cx="128016" cy="4572"/>
+            <a:ext cx="128016" cy="9144"/>
           </a:xfrm>
           <a:prstGeom prst="line">
             <a:avLst/>
@@ -16811,7 +16811,7 @@
         <p:spPr>
           <a:xfrm>
             <a:off x="868680" y="5715000"/>
-            <a:ext cx="5074920" cy="0"/>
+            <a:ext cx="5074920" cy="9144"/>
           </a:xfrm>
           <a:prstGeom prst="line">
             <a:avLst/>
@@ -16834,7 +16834,7 @@
         <p:spPr>
           <a:xfrm>
             <a:off x="868680" y="3657600"/>
-            <a:ext cx="0" cy="2057400"/>
+            <a:ext cx="9144" cy="2057400"/>
           </a:xfrm>
           <a:prstGeom prst="line">
             <a:avLst/>
@@ -16918,7 +16918,7 @@
         <p:spPr>
           <a:xfrm flipV="1">
             <a:off x="868680" y="5707640"/>
-            <a:ext cx="126873" cy="4572"/>
+            <a:ext cx="126873" cy="9144"/>
           </a:xfrm>
           <a:prstGeom prst="line">
             <a:avLst/>
@@ -16941,7 +16941,7 @@
         <p:spPr>
           <a:xfrm flipV="1">
             <a:off x="995553" y="5702031"/>
-            <a:ext cx="126873" cy="5610"/>
+            <a:ext cx="126873" cy="9144"/>
           </a:xfrm>
           <a:prstGeom prst="line">
             <a:avLst/>
@@ -17792,7 +17792,7 @@
         <p:spPr>
           <a:xfrm>
             <a:off x="5689854" y="5702031"/>
-            <a:ext cx="126873" cy="5610"/>
+            <a:ext cx="126873" cy="9144"/>
           </a:xfrm>
           <a:prstGeom prst="line">
             <a:avLst/>
@@ -17815,7 +17815,7 @@
         <p:spPr>
           <a:xfrm>
             <a:off x="5816727" y="5707640"/>
-            <a:ext cx="126873" cy="4572"/>
+            <a:ext cx="126873" cy="9144"/>
           </a:xfrm>
           <a:prstGeom prst="line">
             <a:avLst/>
@@ -18390,7 +18390,7 @@
         <p:spPr>
           <a:xfrm>
             <a:off x="868680" y="4937760"/>
-            <a:ext cx="5120640" cy="0"/>
+            <a:ext cx="5120640" cy="9144"/>
           </a:xfrm>
           <a:prstGeom prst="line">
             <a:avLst/>
@@ -18413,7 +18413,7 @@
         <p:spPr>
           <a:xfrm>
             <a:off x="868680" y="3063240"/>
-            <a:ext cx="0" cy="1874520"/>
+            <a:ext cx="9144" cy="1874520"/>
           </a:xfrm>
           <a:prstGeom prst="line">
             <a:avLst/>
@@ -18475,7 +18475,7 @@
         <p:spPr>
           <a:xfrm flipV="1">
             <a:off x="868680" y="4931054"/>
-            <a:ext cx="123602" cy="4572"/>
+            <a:ext cx="123602" cy="9144"/>
           </a:xfrm>
           <a:prstGeom prst="line">
             <a:avLst/>
@@ -18498,7 +18498,7 @@
         <p:spPr>
           <a:xfrm flipV="1">
             <a:off x="992282" y="4925943"/>
-            <a:ext cx="123602" cy="5111"/>
+            <a:ext cx="123602" cy="9144"/>
           </a:xfrm>
           <a:prstGeom prst="line">
             <a:avLst/>
@@ -18521,7 +18521,7 @@
         <p:spPr>
           <a:xfrm flipV="1">
             <a:off x="1115883" y="4917565"/>
-            <a:ext cx="123602" cy="8378"/>
+            <a:ext cx="123602" cy="9144"/>
           </a:xfrm>
           <a:prstGeom prst="line">
             <a:avLst/>
@@ -19326,7 +19326,7 @@
         <p:spPr>
           <a:xfrm>
             <a:off x="5441941" y="4917565"/>
-            <a:ext cx="123602" cy="8378"/>
+            <a:ext cx="123602" cy="9144"/>
           </a:xfrm>
           <a:prstGeom prst="line">
             <a:avLst/>
@@ -19349,7 +19349,7 @@
         <p:spPr>
           <a:xfrm>
             <a:off x="5565543" y="4925943"/>
-            <a:ext cx="123602" cy="5111"/>
+            <a:ext cx="123602" cy="9144"/>
           </a:xfrm>
           <a:prstGeom prst="line">
             <a:avLst/>
@@ -19372,7 +19372,7 @@
         <p:spPr>
           <a:xfrm>
             <a:off x="5689145" y="4931054"/>
-            <a:ext cx="123602" cy="4572"/>
+            <a:ext cx="123602" cy="9144"/>
           </a:xfrm>
           <a:prstGeom prst="line">
             <a:avLst/>
@@ -19395,7 +19395,7 @@
         <p:spPr>
           <a:xfrm flipV="1">
             <a:off x="1045254" y="4931054"/>
-            <a:ext cx="123602" cy="4572"/>
+            <a:ext cx="123602" cy="9144"/>
           </a:xfrm>
           <a:prstGeom prst="line">
             <a:avLst/>
@@ -19418,7 +19418,7 @@
         <p:spPr>
           <a:xfrm flipV="1">
             <a:off x="1168855" y="4925943"/>
-            <a:ext cx="123602" cy="5111"/>
+            <a:ext cx="123602" cy="9144"/>
           </a:xfrm>
           <a:prstGeom prst="line">
             <a:avLst/>
@@ -19441,7 +19441,7 @@
         <p:spPr>
           <a:xfrm flipV="1">
             <a:off x="1292457" y="4917565"/>
-            <a:ext cx="123602" cy="8378"/>
+            <a:ext cx="123602" cy="9144"/>
           </a:xfrm>
           <a:prstGeom prst="line">
             <a:avLst/>
@@ -20246,7 +20246,7 @@
         <p:spPr>
           <a:xfrm>
             <a:off x="5618515" y="4917565"/>
-            <a:ext cx="123602" cy="8378"/>
+            <a:ext cx="123602" cy="9144"/>
           </a:xfrm>
           <a:prstGeom prst="line">
             <a:avLst/>
@@ -20269,7 +20269,7 @@
         <p:spPr>
           <a:xfrm>
             <a:off x="5742117" y="4925943"/>
-            <a:ext cx="123602" cy="5111"/>
+            <a:ext cx="123602" cy="9144"/>
           </a:xfrm>
           <a:prstGeom prst="line">
             <a:avLst/>
@@ -20292,7 +20292,7 @@
         <p:spPr>
           <a:xfrm>
             <a:off x="5865718" y="4931054"/>
-            <a:ext cx="123602" cy="4572"/>
+            <a:ext cx="123602" cy="9144"/>
           </a:xfrm>
           <a:prstGeom prst="line">
             <a:avLst/>
@@ -20457,7 +20457,7 @@
         <p:spPr>
           <a:xfrm>
             <a:off x="6492240" y="4937760"/>
-            <a:ext cx="5120640" cy="0"/>
+            <a:ext cx="5120640" cy="9144"/>
           </a:xfrm>
           <a:prstGeom prst="line">
             <a:avLst/>
@@ -20480,7 +20480,7 @@
         <p:spPr>
           <a:xfrm>
             <a:off x="6492240" y="3063240"/>
-            <a:ext cx="0" cy="1874520"/>
+            <a:ext cx="9144" cy="1874520"/>
           </a:xfrm>
           <a:prstGeom prst="line">
             <a:avLst/>
@@ -20542,7 +20542,7 @@
         <p:spPr>
           <a:xfrm flipV="1">
             <a:off x="6492240" y="4931054"/>
-            <a:ext cx="99568" cy="4572"/>
+            <a:ext cx="99568" cy="9144"/>
           </a:xfrm>
           <a:prstGeom prst="line">
             <a:avLst/>
@@ -20565,7 +20565,7 @@
         <p:spPr>
           <a:xfrm flipV="1">
             <a:off x="6591808" y="4925943"/>
-            <a:ext cx="99568" cy="5111"/>
+            <a:ext cx="99568" cy="9144"/>
           </a:xfrm>
           <a:prstGeom prst="line">
             <a:avLst/>
@@ -20588,7 +20588,7 @@
         <p:spPr>
           <a:xfrm flipV="1">
             <a:off x="6691376" y="4917565"/>
-            <a:ext cx="99568" cy="8378"/>
+            <a:ext cx="99568" cy="9144"/>
           </a:xfrm>
           <a:prstGeom prst="line">
             <a:avLst/>
@@ -21393,7 +21393,7 @@
         <p:spPr>
           <a:xfrm>
             <a:off x="10176256" y="4917565"/>
-            <a:ext cx="99568" cy="8378"/>
+            <a:ext cx="99568" cy="9144"/>
           </a:xfrm>
           <a:prstGeom prst="line">
             <a:avLst/>
@@ -21416,7 +21416,7 @@
         <p:spPr>
           <a:xfrm>
             <a:off x="10275824" y="4925943"/>
-            <a:ext cx="99568" cy="5111"/>
+            <a:ext cx="99568" cy="9144"/>
           </a:xfrm>
           <a:prstGeom prst="line">
             <a:avLst/>
@@ -21439,7 +21439,7 @@
         <p:spPr>
           <a:xfrm>
             <a:off x="10375392" y="4931054"/>
-            <a:ext cx="99568" cy="4572"/>
+            <a:ext cx="99568" cy="9144"/>
           </a:xfrm>
           <a:prstGeom prst="line">
             <a:avLst/>
@@ -21462,7 +21462,7 @@
         <p:spPr>
           <a:xfrm flipV="1">
             <a:off x="7630160" y="4931054"/>
-            <a:ext cx="99568" cy="4572"/>
+            <a:ext cx="99568" cy="9144"/>
           </a:xfrm>
           <a:prstGeom prst="line">
             <a:avLst/>
@@ -21485,7 +21485,7 @@
         <p:spPr>
           <a:xfrm flipV="1">
             <a:off x="7729728" y="4925943"/>
-            <a:ext cx="99568" cy="5111"/>
+            <a:ext cx="99568" cy="9144"/>
           </a:xfrm>
           <a:prstGeom prst="line">
             <a:avLst/>
@@ -21508,7 +21508,7 @@
         <p:spPr>
           <a:xfrm flipV="1">
             <a:off x="7829296" y="4917565"/>
-            <a:ext cx="99568" cy="8378"/>
+            <a:ext cx="99568" cy="9144"/>
           </a:xfrm>
           <a:prstGeom prst="line">
             <a:avLst/>
@@ -22313,7 +22313,7 @@
         <p:spPr>
           <a:xfrm>
             <a:off x="11314176" y="4917565"/>
-            <a:ext cx="99568" cy="8378"/>
+            <a:ext cx="99568" cy="9144"/>
           </a:xfrm>
           <a:prstGeom prst="line">
             <a:avLst/>
@@ -22336,7 +22336,7 @@
         <p:spPr>
           <a:xfrm>
             <a:off x="11413744" y="4925943"/>
-            <a:ext cx="99568" cy="5111"/>
+            <a:ext cx="99568" cy="9144"/>
           </a:xfrm>
           <a:prstGeom prst="line">
             <a:avLst/>
@@ -22359,7 +22359,7 @@
         <p:spPr>
           <a:xfrm>
             <a:off x="11513312" y="4931054"/>
-            <a:ext cx="99568" cy="4572"/>
+            <a:ext cx="99568" cy="9144"/>
           </a:xfrm>
           <a:prstGeom prst="line">
             <a:avLst/>
@@ -22865,7 +22865,7 @@
         <p:spPr>
           <a:xfrm>
             <a:off x="2797302" y="3474720"/>
-            <a:ext cx="4572" cy="2240280"/>
+            <a:ext cx="9144" cy="2240280"/>
           </a:xfrm>
           <a:prstGeom prst="line">
             <a:avLst/>
@@ -22927,7 +22927,7 @@
         <p:spPr>
           <a:xfrm>
             <a:off x="3313938" y="3848100"/>
-            <a:ext cx="631444" cy="4572"/>
+            <a:ext cx="631444" cy="9144"/>
           </a:xfrm>
           <a:prstGeom prst="line">
             <a:avLst/>
@@ -22950,7 +22950,7 @@
         <p:spPr>
           <a:xfrm>
             <a:off x="3313938" y="3793236"/>
-            <a:ext cx="4572" cy="109728"/>
+            <a:ext cx="9144" cy="109728"/>
           </a:xfrm>
           <a:prstGeom prst="line">
             <a:avLst/>
@@ -22973,7 +22973,7 @@
         <p:spPr>
           <a:xfrm>
             <a:off x="3945382" y="3793236"/>
-            <a:ext cx="4572" cy="109728"/>
+            <a:ext cx="9144" cy="109728"/>
           </a:xfrm>
           <a:prstGeom prst="line">
             <a:avLst/>
@@ -23055,7 +23055,7 @@
         <p:spPr>
           <a:xfrm>
             <a:off x="2625090" y="4594860"/>
-            <a:ext cx="4305300" cy="4572"/>
+            <a:ext cx="4305300" cy="9144"/>
           </a:xfrm>
           <a:prstGeom prst="line">
             <a:avLst/>
@@ -23078,7 +23078,7 @@
         <p:spPr>
           <a:xfrm>
             <a:off x="2625090" y="4539996"/>
-            <a:ext cx="4572" cy="109728"/>
+            <a:ext cx="9144" cy="109728"/>
           </a:xfrm>
           <a:prstGeom prst="line">
             <a:avLst/>
@@ -23101,7 +23101,7 @@
         <p:spPr>
           <a:xfrm>
             <a:off x="6930390" y="4539996"/>
-            <a:ext cx="4572" cy="109728"/>
+            <a:ext cx="9144" cy="109728"/>
           </a:xfrm>
           <a:prstGeom prst="line">
             <a:avLst/>
@@ -23183,7 +23183,7 @@
         <p:spPr>
           <a:xfrm>
             <a:off x="4060190" y="5341620"/>
-            <a:ext cx="2812796" cy="4572"/>
+            <a:ext cx="2812796" cy="9144"/>
           </a:xfrm>
           <a:prstGeom prst="line">
             <a:avLst/>
@@ -23206,7 +23206,7 @@
         <p:spPr>
           <a:xfrm>
             <a:off x="4060190" y="5286756"/>
-            <a:ext cx="4572" cy="109728"/>
+            <a:ext cx="9144" cy="109728"/>
           </a:xfrm>
           <a:prstGeom prst="line">
             <a:avLst/>
@@ -23229,7 +23229,7 @@
         <p:spPr>
           <a:xfrm>
             <a:off x="6872986" y="5286756"/>
-            <a:ext cx="4572" cy="109728"/>
+            <a:ext cx="9144" cy="109728"/>
           </a:xfrm>
           <a:prstGeom prst="line">
             <a:avLst/>
@@ -23272,7 +23272,7 @@
         <p:spPr>
           <a:xfrm>
             <a:off x="2194560" y="5760720"/>
-            <a:ext cx="5166360" cy="4572"/>
+            <a:ext cx="5166360" cy="9144"/>
           </a:xfrm>
           <a:prstGeom prst="line">
             <a:avLst/>
@@ -24426,7 +24426,7 @@
         <p:spPr>
           <a:xfrm>
             <a:off x="7818120" y="5486400"/>
-            <a:ext cx="3776472" cy="0"/>
+            <a:ext cx="3776472" cy="9144"/>
           </a:xfrm>
           <a:prstGeom prst="line">
             <a:avLst/>
@@ -24449,7 +24449,7 @@
         <p:spPr>
           <a:xfrm>
             <a:off x="7818120" y="3246120"/>
-            <a:ext cx="0" cy="2240280"/>
+            <a:ext cx="9144" cy="2240280"/>
           </a:xfrm>
           <a:prstGeom prst="line">
             <a:avLst/>

</xml_diff>